<commit_message>
Slides: add team slide
</commit_message>
<xml_diff>
--- a/slides/Malaria_Phase2_Baseline_Hypothesis_filled.pptx
+++ b/slides/Malaria_Phase2_Baseline_Hypothesis_filled.pptx
@@ -6,6 +6,7 @@
   </p:sldMasterIdLst>
   <p:sldIdLst>
     <p:sldId id="256" r:id="rId2"/>
+    <p:sldId id="277" r:id="rId28"/>
     <p:sldId id="257" r:id="rId3"/>
     <p:sldId id="258" r:id="rId4"/>
     <p:sldId id="259" r:id="rId5"/>
@@ -2926,6 +2927,10 @@
           </a:solidFill>
           <a:ln/>
         </p:spPr>
+        <p:txBody>
+          <a:bodyPr/>
+          <a:p/>
+        </p:txBody>
       </p:sp>
       <p:sp>
         <p:nvSpPr>
@@ -2948,6 +2953,10 @@
           </a:solidFill>
           <a:ln/>
         </p:spPr>
+        <p:txBody>
+          <a:bodyPr/>
+          <a:p/>
+        </p:txBody>
       </p:sp>
       <p:sp>
         <p:nvSpPr>
@@ -2970,6 +2979,10 @@
           </a:solidFill>
           <a:ln/>
         </p:spPr>
+        <p:txBody>
+          <a:bodyPr/>
+          <a:p/>
+        </p:txBody>
       </p:sp>
       <p:sp>
         <p:nvSpPr>
@@ -2992,6 +3005,10 @@
           </a:solidFill>
           <a:ln/>
         </p:spPr>
+        <p:txBody>
+          <a:bodyPr/>
+          <a:p/>
+        </p:txBody>
       </p:sp>
       <p:sp>
         <p:nvSpPr>
@@ -3014,6 +3031,10 @@
           </a:solidFill>
           <a:ln/>
         </p:spPr>
+        <p:txBody>
+          <a:bodyPr/>
+          <a:p/>
+        </p:txBody>
       </p:sp>
       <p:sp>
         <p:nvSpPr>
@@ -3036,6 +3057,10 @@
           </a:solidFill>
           <a:ln/>
         </p:spPr>
+        <p:txBody>
+          <a:bodyPr/>
+          <a:p/>
+        </p:txBody>
       </p:sp>
       <p:sp>
         <p:nvSpPr>
@@ -3058,6 +3083,10 @@
           </a:solidFill>
           <a:ln/>
         </p:spPr>
+        <p:txBody>
+          <a:bodyPr/>
+          <a:p/>
+        </p:txBody>
       </p:sp>
       <p:sp>
         <p:nvSpPr>
@@ -3080,6 +3109,10 @@
           </a:solidFill>
           <a:ln/>
         </p:spPr>
+        <p:txBody>
+          <a:bodyPr/>
+          <a:p/>
+        </p:txBody>
       </p:sp>
       <p:pic>
         <p:nvPicPr>
@@ -3243,6 +3276,10 @@
           </a:solidFill>
           <a:ln/>
         </p:spPr>
+        <p:txBody>
+          <a:bodyPr/>
+          <a:p/>
+        </p:txBody>
       </p:sp>
       <p:sp>
         <p:nvSpPr>
@@ -3309,6 +3346,10 @@
             <a:prstDash val="solid"/>
           </a:ln>
         </p:spPr>
+        <p:txBody>
+          <a:bodyPr/>
+          <a:p/>
+        </p:txBody>
       </p:sp>
       <p:sp>
         <p:nvSpPr>
@@ -3414,6 +3455,10 @@
             <a:prstDash val="solid"/>
           </a:ln>
         </p:spPr>
+        <p:txBody>
+          <a:bodyPr/>
+          <a:p/>
+        </p:txBody>
       </p:sp>
       <p:sp>
         <p:nvSpPr>
@@ -3519,6 +3564,10 @@
             <a:prstDash val="solid"/>
           </a:ln>
         </p:spPr>
+        <p:txBody>
+          <a:bodyPr/>
+          <a:p/>
+        </p:txBody>
       </p:sp>
       <p:sp>
         <p:nvSpPr>
@@ -3624,6 +3673,10 @@
             <a:prstDash val="solid"/>
           </a:ln>
         </p:spPr>
+        <p:txBody>
+          <a:bodyPr/>
+          <a:p/>
+        </p:txBody>
       </p:sp>
       <p:sp>
         <p:nvSpPr>
@@ -3920,6 +3973,10 @@
             </a:outerShdw>
           </a:effectLst>
         </p:spPr>
+        <p:txBody>
+          <a:bodyPr/>
+          <a:p/>
+        </p:txBody>
       </p:sp>
       <p:sp>
         <p:nvSpPr>
@@ -3940,6 +3997,10 @@
           </a:solidFill>
           <a:ln/>
         </p:spPr>
+        <p:txBody>
+          <a:bodyPr/>
+          <a:p/>
+        </p:txBody>
       </p:sp>
       <p:pic>
         <p:nvPicPr>
@@ -4152,6 +4213,10 @@
             </a:outerShdw>
           </a:effectLst>
         </p:spPr>
+        <p:txBody>
+          <a:bodyPr/>
+          <a:p/>
+        </p:txBody>
       </p:sp>
       <p:sp>
         <p:nvSpPr>
@@ -4172,6 +4237,10 @@
           </a:solidFill>
           <a:ln/>
         </p:spPr>
+        <p:txBody>
+          <a:bodyPr/>
+          <a:p/>
+        </p:txBody>
       </p:sp>
       <p:pic>
         <p:nvPicPr>
@@ -4372,6 +4441,10 @@
           </a:solidFill>
           <a:ln/>
         </p:spPr>
+        <p:txBody>
+          <a:bodyPr/>
+          <a:p/>
+        </p:txBody>
       </p:sp>
       <p:sp>
         <p:nvSpPr>
@@ -4392,6 +4465,10 @@
           </a:solidFill>
           <a:ln/>
         </p:spPr>
+        <p:txBody>
+          <a:bodyPr/>
+          <a:p/>
+        </p:txBody>
       </p:sp>
       <p:pic>
         <p:nvPicPr>
@@ -4548,7 +4625,7 @@
                 <a:ea typeface="Calibri" pitchFamily="34" charset="-122"/>
                 <a:cs typeface="Calibri" pitchFamily="34" charset="-120"/>
               </a:rPr>
-              <a:t>10</a:t>
+              <a:t>11</a:t>
             </a:r>
             <a:endParaRPr lang="en-US" sz="1000" dirty="0"/>
           </a:p>
@@ -8049,7 +8126,7 @@
                 <a:ea typeface="Calibri" pitchFamily="34" charset="-122"/>
                 <a:cs typeface="Calibri" pitchFamily="34" charset="-120"/>
               </a:rPr>
-              <a:t>11</a:t>
+              <a:t>12</a:t>
             </a:r>
             <a:endParaRPr lang="en-US" sz="1000" dirty="0"/>
           </a:p>
@@ -8246,6 +8323,10 @@
             </a:outerShdw>
           </a:effectLst>
         </p:spPr>
+        <p:txBody>
+          <a:bodyPr/>
+          <a:p/>
+        </p:txBody>
       </p:sp>
       <p:sp>
         <p:nvSpPr>
@@ -8266,6 +8347,10 @@
           </a:solidFill>
           <a:ln/>
         </p:spPr>
+        <p:txBody>
+          <a:bodyPr/>
+          <a:p/>
+        </p:txBody>
       </p:sp>
       <p:pic>
         <p:nvPicPr>
@@ -8349,6 +8434,10 @@
           </a:solidFill>
           <a:ln/>
         </p:spPr>
+        <p:txBody>
+          <a:bodyPr/>
+          <a:p/>
+        </p:txBody>
       </p:sp>
       <p:sp>
         <p:nvSpPr>
@@ -8450,6 +8539,10 @@
           </a:solidFill>
           <a:ln/>
         </p:spPr>
+        <p:txBody>
+          <a:bodyPr/>
+          <a:p/>
+        </p:txBody>
       </p:sp>
       <p:sp>
         <p:nvSpPr>
@@ -8551,6 +8644,10 @@
           </a:solidFill>
           <a:ln/>
         </p:spPr>
+        <p:txBody>
+          <a:bodyPr/>
+          <a:p/>
+        </p:txBody>
       </p:sp>
       <p:sp>
         <p:nvSpPr>
@@ -8705,7 +8802,7 @@
                 <a:ea typeface="Calibri" pitchFamily="34" charset="-122"/>
                 <a:cs typeface="Calibri" pitchFamily="34" charset="-120"/>
               </a:rPr>
-              <a:t>12</a:t>
+              <a:t>13</a:t>
             </a:r>
             <a:endParaRPr lang="en-US" sz="1000" dirty="0"/>
           </a:p>
@@ -8757,6 +8854,10 @@
           </a:solidFill>
           <a:ln/>
         </p:spPr>
+        <p:txBody>
+          <a:bodyPr/>
+          <a:p/>
+        </p:txBody>
       </p:sp>
       <p:sp>
         <p:nvSpPr>
@@ -8779,6 +8880,10 @@
           </a:solidFill>
           <a:ln/>
         </p:spPr>
+        <p:txBody>
+          <a:bodyPr/>
+          <a:p/>
+        </p:txBody>
       </p:sp>
       <p:sp>
         <p:nvSpPr>
@@ -8801,6 +8906,10 @@
           </a:solidFill>
           <a:ln/>
         </p:spPr>
+        <p:txBody>
+          <a:bodyPr/>
+          <a:p/>
+        </p:txBody>
       </p:sp>
       <p:sp>
         <p:nvSpPr>
@@ -8906,6 +9015,10 @@
             <a:prstDash val="solid"/>
           </a:ln>
         </p:spPr>
+        <p:txBody>
+          <a:bodyPr/>
+          <a:p/>
+        </p:txBody>
       </p:sp>
       <p:sp>
         <p:nvSpPr>
@@ -8926,6 +9039,10 @@
           </a:solidFill>
           <a:ln/>
         </p:spPr>
+        <p:txBody>
+          <a:bodyPr/>
+          <a:p/>
+        </p:txBody>
       </p:sp>
       <p:pic>
         <p:nvPicPr>
@@ -9097,6 +9214,10 @@
             <a:prstDash val="solid"/>
           </a:ln>
         </p:spPr>
+        <p:txBody>
+          <a:bodyPr/>
+          <a:p/>
+        </p:txBody>
       </p:sp>
       <p:sp>
         <p:nvSpPr>
@@ -9117,6 +9238,10 @@
           </a:solidFill>
           <a:ln/>
         </p:spPr>
+        <p:txBody>
+          <a:bodyPr/>
+          <a:p/>
+        </p:txBody>
       </p:sp>
       <p:pic>
         <p:nvPicPr>
@@ -9288,6 +9413,10 @@
             <a:prstDash val="solid"/>
           </a:ln>
         </p:spPr>
+        <p:txBody>
+          <a:bodyPr/>
+          <a:p/>
+        </p:txBody>
       </p:sp>
       <p:sp>
         <p:nvSpPr>
@@ -9308,6 +9437,10 @@
           </a:solidFill>
           <a:ln/>
         </p:spPr>
+        <p:txBody>
+          <a:bodyPr/>
+          <a:p/>
+        </p:txBody>
       </p:sp>
       <p:pic>
         <p:nvPicPr>
@@ -9479,6 +9612,10 @@
             <a:prstDash val="solid"/>
           </a:ln>
         </p:spPr>
+        <p:txBody>
+          <a:bodyPr/>
+          <a:p/>
+        </p:txBody>
       </p:sp>
       <p:sp>
         <p:nvSpPr>
@@ -9499,6 +9636,10 @@
           </a:solidFill>
           <a:ln/>
         </p:spPr>
+        <p:txBody>
+          <a:bodyPr/>
+          <a:p/>
+        </p:txBody>
       </p:sp>
       <p:pic>
         <p:nvPicPr>
@@ -9812,6 +9953,10 @@
             <a:prstDash val="solid"/>
           </a:ln>
         </p:spPr>
+        <p:txBody>
+          <a:bodyPr/>
+          <a:p/>
+        </p:txBody>
       </p:sp>
       <p:sp>
         <p:nvSpPr>
@@ -9832,6 +9977,10 @@
           </a:solidFill>
           <a:ln/>
         </p:spPr>
+        <p:txBody>
+          <a:bodyPr/>
+          <a:p/>
+        </p:txBody>
       </p:sp>
       <p:pic>
         <p:nvPicPr>
@@ -9922,6 +10071,10 @@
             <a:prstDash val="solid"/>
           </a:ln>
         </p:spPr>
+        <p:txBody>
+          <a:bodyPr/>
+          <a:p/>
+        </p:txBody>
       </p:sp>
       <p:sp>
         <p:nvSpPr>
@@ -10030,6 +10183,10 @@
             <a:prstDash val="solid"/>
           </a:ln>
         </p:spPr>
+        <p:txBody>
+          <a:bodyPr/>
+          <a:p/>
+        </p:txBody>
       </p:sp>
       <p:sp>
         <p:nvSpPr>
@@ -10050,6 +10207,10 @@
           </a:solidFill>
           <a:ln/>
         </p:spPr>
+        <p:txBody>
+          <a:bodyPr/>
+          <a:p/>
+        </p:txBody>
       </p:sp>
       <p:pic>
         <p:nvPicPr>
@@ -10140,6 +10301,10 @@
             <a:prstDash val="solid"/>
           </a:ln>
         </p:spPr>
+        <p:txBody>
+          <a:bodyPr/>
+          <a:p/>
+        </p:txBody>
       </p:sp>
       <p:sp>
         <p:nvSpPr>
@@ -10248,6 +10413,10 @@
             <a:prstDash val="solid"/>
           </a:ln>
         </p:spPr>
+        <p:txBody>
+          <a:bodyPr/>
+          <a:p/>
+        </p:txBody>
       </p:sp>
       <p:sp>
         <p:nvSpPr>
@@ -10268,6 +10437,10 @@
           </a:solidFill>
           <a:ln/>
         </p:spPr>
+        <p:txBody>
+          <a:bodyPr/>
+          <a:p/>
+        </p:txBody>
       </p:sp>
       <p:pic>
         <p:nvPicPr>
@@ -10358,6 +10531,10 @@
             <a:prstDash val="solid"/>
           </a:ln>
         </p:spPr>
+        <p:txBody>
+          <a:bodyPr/>
+          <a:p/>
+        </p:txBody>
       </p:sp>
       <p:sp>
         <p:nvSpPr>
@@ -10466,6 +10643,10 @@
             <a:prstDash val="solid"/>
           </a:ln>
         </p:spPr>
+        <p:txBody>
+          <a:bodyPr/>
+          <a:p/>
+        </p:txBody>
       </p:sp>
       <p:sp>
         <p:nvSpPr>
@@ -10486,6 +10667,10 @@
           </a:solidFill>
           <a:ln/>
         </p:spPr>
+        <p:txBody>
+          <a:bodyPr/>
+          <a:p/>
+        </p:txBody>
       </p:sp>
       <p:pic>
         <p:nvPicPr>
@@ -10576,6 +10761,10 @@
             <a:prstDash val="solid"/>
           </a:ln>
         </p:spPr>
+        <p:txBody>
+          <a:bodyPr/>
+          <a:p/>
+        </p:txBody>
       </p:sp>
       <p:sp>
         <p:nvSpPr>
@@ -10730,7 +10919,7 @@
                 <a:ea typeface="Calibri" pitchFamily="34" charset="-122"/>
                 <a:cs typeface="Calibri" pitchFamily="34" charset="-120"/>
               </a:rPr>
-              <a:t>14</a:t>
+              <a:t>15</a:t>
             </a:r>
             <a:endParaRPr lang="en-US" sz="1000" dirty="0"/>
           </a:p>
@@ -10782,6 +10971,10 @@
           </a:solidFill>
           <a:ln/>
         </p:spPr>
+        <p:txBody>
+          <a:bodyPr/>
+          <a:p/>
+        </p:txBody>
       </p:sp>
       <p:sp>
         <p:nvSpPr>
@@ -10804,6 +10997,10 @@
           </a:solidFill>
           <a:ln/>
         </p:spPr>
+        <p:txBody>
+          <a:bodyPr/>
+          <a:p/>
+        </p:txBody>
       </p:sp>
       <p:sp>
         <p:nvSpPr>
@@ -10909,6 +11106,10 @@
             <a:prstDash val="solid"/>
           </a:ln>
         </p:spPr>
+        <p:txBody>
+          <a:bodyPr/>
+          <a:p/>
+        </p:txBody>
       </p:sp>
       <p:sp>
         <p:nvSpPr>
@@ -11030,6 +11231,10 @@
             <a:prstDash val="solid"/>
           </a:ln>
         </p:spPr>
+        <p:txBody>
+          <a:bodyPr/>
+          <a:p/>
+        </p:txBody>
       </p:sp>
       <p:sp>
         <p:nvSpPr>
@@ -11050,6 +11255,10 @@
           </a:solidFill>
           <a:ln/>
         </p:spPr>
+        <p:txBody>
+          <a:bodyPr/>
+          <a:p/>
+        </p:txBody>
       </p:sp>
       <p:sp>
         <p:nvSpPr>
@@ -11193,6 +11402,10 @@
           </a:solidFill>
           <a:ln/>
         </p:spPr>
+        <p:txBody>
+          <a:bodyPr/>
+          <a:p/>
+        </p:txBody>
       </p:sp>
       <p:sp>
         <p:nvSpPr>
@@ -11336,6 +11549,10 @@
           </a:solidFill>
           <a:ln/>
         </p:spPr>
+        <p:txBody>
+          <a:bodyPr/>
+          <a:p/>
+        </p:txBody>
       </p:sp>
       <p:sp>
         <p:nvSpPr>
@@ -11479,6 +11696,10 @@
           </a:solidFill>
           <a:ln/>
         </p:spPr>
+        <p:txBody>
+          <a:bodyPr/>
+          <a:p/>
+        </p:txBody>
       </p:sp>
       <p:sp>
         <p:nvSpPr>
@@ -11622,6 +11843,10 @@
           </a:solidFill>
           <a:ln/>
         </p:spPr>
+        <p:txBody>
+          <a:bodyPr/>
+          <a:p/>
+        </p:txBody>
       </p:sp>
       <p:sp>
         <p:nvSpPr>
@@ -14860,7 +15085,7 @@
                 </a:solidFill>
                 <a:latin typeface="Calibri"/>
               </a:rPr>
-              <a:t>17</a:t>
+              <a:t>18</a:t>
             </a:r>
           </a:p>
         </p:txBody>
@@ -16468,7 +16693,7 @@
                 </a:solidFill>
                 <a:latin typeface="Calibri"/>
               </a:rPr>
-              <a:t>18</a:t>
+              <a:t>19</a:t>
             </a:r>
           </a:p>
         </p:txBody>
@@ -17729,6 +17954,10 @@
             </a:outerShdw>
           </a:effectLst>
         </p:spPr>
+        <p:txBody>
+          <a:bodyPr/>
+          <a:p/>
+        </p:txBody>
       </p:sp>
       <p:sp>
         <p:nvSpPr>
@@ -17749,6 +17978,10 @@
           </a:solidFill>
           <a:ln/>
         </p:spPr>
+        <p:txBody>
+          <a:bodyPr/>
+          <a:p/>
+        </p:txBody>
       </p:sp>
       <p:pic>
         <p:nvPicPr>
@@ -17888,6 +18121,10 @@
             </a:outerShdw>
           </a:effectLst>
         </p:spPr>
+        <p:txBody>
+          <a:bodyPr/>
+          <a:p/>
+        </p:txBody>
       </p:sp>
       <p:sp>
         <p:nvSpPr>
@@ -17908,6 +18145,10 @@
           </a:solidFill>
           <a:ln/>
         </p:spPr>
+        <p:txBody>
+          <a:bodyPr/>
+          <a:p/>
+        </p:txBody>
       </p:sp>
       <p:pic>
         <p:nvPicPr>
@@ -18047,6 +18288,10 @@
             </a:outerShdw>
           </a:effectLst>
         </p:spPr>
+        <p:txBody>
+          <a:bodyPr/>
+          <a:p/>
+        </p:txBody>
       </p:sp>
       <p:sp>
         <p:nvSpPr>
@@ -18067,6 +18312,10 @@
           </a:solidFill>
           <a:ln/>
         </p:spPr>
+        <p:txBody>
+          <a:bodyPr/>
+          <a:p/>
+        </p:txBody>
       </p:sp>
       <p:pic>
         <p:nvPicPr>
@@ -18194,6 +18443,10 @@
           </a:solidFill>
           <a:ln/>
         </p:spPr>
+        <p:txBody>
+          <a:bodyPr/>
+          <a:p/>
+        </p:txBody>
       </p:sp>
       <p:sp>
         <p:nvSpPr>
@@ -18214,6 +18467,10 @@
           </a:solidFill>
           <a:ln/>
         </p:spPr>
+        <p:txBody>
+          <a:bodyPr/>
+          <a:p/>
+        </p:txBody>
       </p:sp>
       <p:pic>
         <p:nvPicPr>
@@ -18370,7 +18627,7 @@
                 <a:ea typeface="Calibri" pitchFamily="34" charset="-122"/>
                 <a:cs typeface="Calibri" pitchFamily="34" charset="-120"/>
               </a:rPr>
-              <a:t>2</a:t>
+              <a:t>3</a:t>
             </a:r>
             <a:endParaRPr lang="en-US" sz="1000" dirty="0"/>
           </a:p>
@@ -19699,7 +19956,7 @@
                 </a:solidFill>
                 <a:latin typeface="Calibri"/>
               </a:rPr>
-              <a:t>20</a:t>
+              <a:t>21</a:t>
             </a:r>
           </a:p>
         </p:txBody>
@@ -20345,9 +20602,1041 @@
                 <a:ea typeface="Calibri" pitchFamily="34" charset="-122"/>
                 <a:cs typeface="Calibri" pitchFamily="34" charset="-120"/>
               </a:rPr>
-              <a:t>21</a:t>
+              <a:t>22</a:t>
             </a:r>
             <a:endParaRPr lang="en-US" sz="1000" dirty="0"/>
+          </a:p>
+        </p:txBody>
+      </p:sp>
+    </p:spTree>
+  </p:cSld>
+  <p:clrMapOvr>
+    <a:masterClrMapping/>
+  </p:clrMapOvr>
+</p:sld>
+</file>
+
+<file path=ppt/slides/slide22.xml><?xml version="1.0" encoding="utf-8"?>
+<p:sld xmlns:a="http://schemas.openxmlformats.org/drawingml/2006/main" xmlns:p="http://schemas.openxmlformats.org/presentationml/2006/main" xmlns:r="http://schemas.openxmlformats.org/officeDocument/2006/relationships">
+  <p:cSld>
+    <p:spTree>
+      <p:nvGrpSpPr>
+        <p:cNvPr id="2" name=""/>
+        <p:cNvGrpSpPr/>
+        <p:nvPr/>
+      </p:nvGrpSpPr>
+      <p:grpSpPr/>
+      <p:sp>
+        <p:nvSpPr>
+          <p:cNvPr id="3" name="Oval 1"/>
+          <p:cNvSpPr/>
+          <p:nvPr/>
+        </p:nvSpPr>
+        <p:spPr>
+          <a:xfrm>
+            <a:off x="10972800" y="5669280"/>
+            <a:ext cx="1097280" cy="1097280"/>
+          </a:xfrm>
+          <a:prstGeom prst="ellipse">
+            <a:avLst/>
+          </a:prstGeom>
+          <a:solidFill>
+            <a:srgbClr val="137C8E"/>
+          </a:solidFill>
+          <a:ln>
+            <a:noFill/>
+          </a:ln>
+          <a:effectLst/>
+        </p:spPr>
+        <p:style>
+          <a:lnRef idx="1">
+            <a:schemeClr val="accent1"/>
+          </a:lnRef>
+          <a:fillRef idx="3">
+            <a:schemeClr val="accent1"/>
+          </a:fillRef>
+          <a:effectRef idx="2">
+            <a:schemeClr val="accent1"/>
+          </a:effectRef>
+          <a:fontRef idx="minor">
+            <a:schemeClr val="lt1"/>
+          </a:fontRef>
+        </p:style>
+        <p:txBody>
+          <a:bodyPr rtlCol="0" anchor="ctr"/>
+          <a:lstStyle/>
+          <a:p/>
+        </p:txBody>
+      </p:sp>
+      <p:sp>
+        <p:nvSpPr>
+          <p:cNvPr id="4" name="Oval 2"/>
+          <p:cNvSpPr/>
+          <p:nvPr/>
+        </p:nvSpPr>
+        <p:spPr>
+          <a:xfrm>
+            <a:off x="11521440" y="1188720"/>
+            <a:ext cx="548640" cy="548640"/>
+          </a:xfrm>
+          <a:prstGeom prst="ellipse">
+            <a:avLst/>
+          </a:prstGeom>
+          <a:solidFill>
+            <a:srgbClr val="2EA79B"/>
+          </a:solidFill>
+          <a:ln>
+            <a:noFill/>
+          </a:ln>
+          <a:effectLst/>
+        </p:spPr>
+        <p:style>
+          <a:lnRef idx="1">
+            <a:schemeClr val="accent1"/>
+          </a:lnRef>
+          <a:fillRef idx="3">
+            <a:schemeClr val="accent1"/>
+          </a:fillRef>
+          <a:effectRef idx="2">
+            <a:schemeClr val="accent1"/>
+          </a:effectRef>
+          <a:fontRef idx="minor">
+            <a:schemeClr val="lt1"/>
+          </a:fontRef>
+        </p:style>
+        <p:txBody>
+          <a:bodyPr rtlCol="0" anchor="ctr"/>
+          <a:lstStyle/>
+          <a:p/>
+        </p:txBody>
+      </p:sp>
+      <p:sp>
+        <p:nvSpPr>
+          <p:cNvPr id="5" name="TextBox 3"/>
+          <p:cNvSpPr txBox="1"/>
+          <p:nvPr/>
+        </p:nvSpPr>
+        <p:spPr>
+          <a:xfrm>
+            <a:off x="685800" y="548640"/>
+            <a:ext cx="10058400" cy="320040"/>
+          </a:xfrm>
+          <a:prstGeom prst="rect">
+            <a:avLst/>
+          </a:prstGeom>
+          <a:noFill/>
+        </p:spPr>
+        <p:txBody>
+          <a:bodyPr wrap="square" lIns="0" rIns="0" tIns="0" bIns="0" anchor="t">
+            <a:spAutoFit/>
+          </a:bodyPr>
+          <a:lstStyle/>
+          <a:p>
+            <a:pPr algn="l"/>
+            <a:r>
+              <a:rPr sz="1300" b="1" i="0">
+                <a:solidFill>
+                  <a:srgbClr val="2EA79B"/>
+                </a:solidFill>
+                <a:latin typeface="Calibri"/>
+              </a:rPr>
+              <a:t>OUR TEAM</a:t>
+            </a:r>
+          </a:p>
+        </p:txBody>
+      </p:sp>
+      <p:sp>
+        <p:nvSpPr>
+          <p:cNvPr id="6" name="TextBox 4"/>
+          <p:cNvSpPr txBox="1"/>
+          <p:nvPr/>
+        </p:nvSpPr>
+        <p:spPr>
+          <a:xfrm>
+            <a:off x="685800" y="896112"/>
+            <a:ext cx="10972800" cy="640080"/>
+          </a:xfrm>
+          <a:prstGeom prst="rect">
+            <a:avLst/>
+          </a:prstGeom>
+          <a:noFill/>
+        </p:spPr>
+        <p:txBody>
+          <a:bodyPr wrap="square" lIns="0" rIns="0" tIns="0" bIns="0" anchor="t">
+            <a:spAutoFit/>
+          </a:bodyPr>
+          <a:lstStyle/>
+          <a:p>
+            <a:pPr algn="l"/>
+            <a:r>
+              <a:rPr sz="3000" b="1" i="0">
+                <a:solidFill>
+                  <a:srgbClr val="FFFFFF"/>
+                </a:solidFill>
+                <a:latin typeface="Cambria"/>
+              </a:rPr>
+              <a:t>Four people, four jobs</a:t>
+            </a:r>
+          </a:p>
+        </p:txBody>
+      </p:sp>
+      <p:sp>
+        <p:nvSpPr>
+          <p:cNvPr id="7" name="Rounded Rectangle 8"/>
+          <p:cNvSpPr/>
+          <p:nvPr/>
+        </p:nvSpPr>
+        <p:spPr>
+          <a:xfrm>
+            <a:off x="685800" y="2011680"/>
+            <a:ext cx="2571750" cy="2743200"/>
+          </a:xfrm>
+          <a:prstGeom prst="roundRect">
+            <a:avLst>
+              <a:gd name="adj" fmla="val 6000"/>
+            </a:avLst>
+          </a:prstGeom>
+          <a:solidFill>
+            <a:srgbClr val="15455A"/>
+          </a:solidFill>
+          <a:ln w="12700">
+            <a:solidFill>
+              <a:srgbClr val="0E6274"/>
+            </a:solidFill>
+          </a:ln>
+          <a:effectLst/>
+        </p:spPr>
+        <p:style>
+          <a:lnRef idx="1">
+            <a:schemeClr val="accent1"/>
+          </a:lnRef>
+          <a:fillRef idx="3">
+            <a:schemeClr val="accent1"/>
+          </a:fillRef>
+          <a:effectRef idx="2">
+            <a:schemeClr val="accent1"/>
+          </a:effectRef>
+          <a:fontRef idx="minor">
+            <a:schemeClr val="lt1"/>
+          </a:fontRef>
+        </p:style>
+        <p:txBody>
+          <a:bodyPr rtlCol="0" anchor="ctr"/>
+          <a:lstStyle/>
+          <a:p/>
+        </p:txBody>
+      </p:sp>
+      <p:sp>
+        <p:nvSpPr>
+          <p:cNvPr id="8" name="Oval 9"/>
+          <p:cNvSpPr/>
+          <p:nvPr/>
+        </p:nvSpPr>
+        <p:spPr>
+          <a:xfrm>
+            <a:off x="960120" y="2331720"/>
+            <a:ext cx="822960" cy="822960"/>
+          </a:xfrm>
+          <a:prstGeom prst="ellipse">
+            <a:avLst/>
+          </a:prstGeom>
+          <a:solidFill>
+            <a:srgbClr val="CC4A3F"/>
+          </a:solidFill>
+          <a:ln>
+            <a:noFill/>
+          </a:ln>
+          <a:effectLst/>
+        </p:spPr>
+        <p:style>
+          <a:lnRef idx="1">
+            <a:schemeClr val="accent1"/>
+          </a:lnRef>
+          <a:fillRef idx="3">
+            <a:schemeClr val="accent1"/>
+          </a:fillRef>
+          <a:effectRef idx="2">
+            <a:schemeClr val="accent1"/>
+          </a:effectRef>
+          <a:fontRef idx="minor">
+            <a:schemeClr val="lt1"/>
+          </a:fontRef>
+        </p:style>
+        <p:txBody>
+          <a:bodyPr rtlCol="0" anchor="ctr" lIns="0" rIns="0" tIns="0" bIns="0"/>
+          <a:lstStyle/>
+          <a:p>
+            <a:pPr algn="ctr"/>
+            <a:r>
+              <a:rPr sz="2000" b="1">
+                <a:solidFill>
+                  <a:srgbClr val="FFFFFF"/>
+                </a:solidFill>
+                <a:latin typeface="Cambria"/>
+              </a:rPr>
+              <a:t>AJ</a:t>
+            </a:r>
+          </a:p>
+        </p:txBody>
+      </p:sp>
+      <p:sp>
+        <p:nvSpPr>
+          <p:cNvPr id="9" name="TextBox 11"/>
+          <p:cNvSpPr txBox="1"/>
+          <p:nvPr/>
+        </p:nvSpPr>
+        <p:spPr>
+          <a:xfrm>
+            <a:off x="960120" y="3383280"/>
+            <a:ext cx="2023110" cy="365760"/>
+          </a:xfrm>
+          <a:prstGeom prst="rect">
+            <a:avLst/>
+          </a:prstGeom>
+          <a:noFill/>
+        </p:spPr>
+        <p:txBody>
+          <a:bodyPr wrap="square" lIns="0" rIns="0" tIns="0" bIns="0" anchor="t">
+            <a:spAutoFit/>
+          </a:bodyPr>
+          <a:lstStyle/>
+          <a:p>
+            <a:pPr algn="l"/>
+            <a:r>
+              <a:rPr sz="1600" b="1" i="0">
+                <a:solidFill>
+                  <a:srgbClr val="FFFFFF"/>
+                </a:solidFill>
+                <a:latin typeface="Cambria"/>
+              </a:rPr>
+              <a:t>Amathziah J</a:t>
+            </a:r>
+          </a:p>
+        </p:txBody>
+      </p:sp>
+      <p:sp>
+        <p:nvSpPr>
+          <p:cNvPr id="10" name="TextBox 23"/>
+          <p:cNvSpPr txBox="1"/>
+          <p:nvPr/>
+        </p:nvSpPr>
+        <p:spPr>
+          <a:xfrm>
+            <a:off x="960120" y="3886200"/>
+            <a:ext cx="2023110" cy="228600"/>
+          </a:xfrm>
+          <a:prstGeom prst="rect">
+            <a:avLst/>
+          </a:prstGeom>
+          <a:noFill/>
+        </p:spPr>
+        <p:txBody>
+          <a:bodyPr wrap="square" lIns="0" rIns="0" tIns="0" bIns="0" anchor="t">
+            <a:spAutoFit/>
+          </a:bodyPr>
+          <a:lstStyle/>
+          <a:p>
+            <a:pPr algn="l"/>
+            <a:r>
+              <a:rPr sz="1100" b="1" i="0">
+                <a:solidFill>
+                  <a:srgbClr val="2EA79B"/>
+                </a:solidFill>
+                <a:latin typeface="Calibri"/>
+              </a:rPr>
+              <a:t>ROLE</a:t>
+            </a:r>
+          </a:p>
+        </p:txBody>
+      </p:sp>
+      <p:sp>
+        <p:nvSpPr>
+          <p:cNvPr id="11" name="TextBox 12"/>
+          <p:cNvSpPr txBox="1"/>
+          <p:nvPr/>
+        </p:nvSpPr>
+        <p:spPr>
+          <a:xfrm>
+            <a:off x="960120" y="4160520"/>
+            <a:ext cx="2023110" cy="457200"/>
+          </a:xfrm>
+          <a:prstGeom prst="rect">
+            <a:avLst/>
+          </a:prstGeom>
+          <a:noFill/>
+        </p:spPr>
+        <p:txBody>
+          <a:bodyPr wrap="square" lIns="0" rIns="0" tIns="0" bIns="0" anchor="t">
+            <a:spAutoFit/>
+          </a:bodyPr>
+          <a:lstStyle/>
+          <a:p>
+            <a:pPr algn="l"/>
+            <a:r>
+              <a:rPr sz="1400" b="0" i="0">
+                <a:solidFill>
+                  <a:srgbClr val="D5E6EA"/>
+                </a:solidFill>
+                <a:latin typeface="Calibri"/>
+              </a:rPr>
+              <a:t>Kaggle experiments, repository</a:t>
+            </a:r>
+          </a:p>
+        </p:txBody>
+      </p:sp>
+      <p:sp>
+        <p:nvSpPr>
+          <p:cNvPr id="12" name="Rounded Rectangle 8"/>
+          <p:cNvSpPr/>
+          <p:nvPr/>
+        </p:nvSpPr>
+        <p:spPr>
+          <a:xfrm>
+            <a:off x="3440430" y="2011680"/>
+            <a:ext cx="2571750" cy="2743200"/>
+          </a:xfrm>
+          <a:prstGeom prst="roundRect">
+            <a:avLst>
+              <a:gd name="adj" fmla="val 6000"/>
+            </a:avLst>
+          </a:prstGeom>
+          <a:solidFill>
+            <a:srgbClr val="15455A"/>
+          </a:solidFill>
+          <a:ln w="12700">
+            <a:solidFill>
+              <a:srgbClr val="0E6274"/>
+            </a:solidFill>
+          </a:ln>
+          <a:effectLst/>
+        </p:spPr>
+        <p:style>
+          <a:lnRef idx="1">
+            <a:schemeClr val="accent1"/>
+          </a:lnRef>
+          <a:fillRef idx="3">
+            <a:schemeClr val="accent1"/>
+          </a:fillRef>
+          <a:effectRef idx="2">
+            <a:schemeClr val="accent1"/>
+          </a:effectRef>
+          <a:fontRef idx="minor">
+            <a:schemeClr val="lt1"/>
+          </a:fontRef>
+        </p:style>
+        <p:txBody>
+          <a:bodyPr rtlCol="0" anchor="ctr"/>
+          <a:lstStyle/>
+          <a:p/>
+        </p:txBody>
+      </p:sp>
+      <p:sp>
+        <p:nvSpPr>
+          <p:cNvPr id="13" name="Oval 9"/>
+          <p:cNvSpPr/>
+          <p:nvPr/>
+        </p:nvSpPr>
+        <p:spPr>
+          <a:xfrm>
+            <a:off x="3714750" y="2331720"/>
+            <a:ext cx="822960" cy="822960"/>
+          </a:xfrm>
+          <a:prstGeom prst="ellipse">
+            <a:avLst/>
+          </a:prstGeom>
+          <a:solidFill>
+            <a:srgbClr val="8A43B0"/>
+          </a:solidFill>
+          <a:ln>
+            <a:noFill/>
+          </a:ln>
+          <a:effectLst/>
+        </p:spPr>
+        <p:style>
+          <a:lnRef idx="1">
+            <a:schemeClr val="accent1"/>
+          </a:lnRef>
+          <a:fillRef idx="3">
+            <a:schemeClr val="accent1"/>
+          </a:fillRef>
+          <a:effectRef idx="2">
+            <a:schemeClr val="accent1"/>
+          </a:effectRef>
+          <a:fontRef idx="minor">
+            <a:schemeClr val="lt1"/>
+          </a:fontRef>
+        </p:style>
+        <p:txBody>
+          <a:bodyPr rtlCol="0" anchor="ctr" lIns="0" rIns="0" tIns="0" bIns="0"/>
+          <a:lstStyle/>
+          <a:p>
+            <a:pPr algn="ctr"/>
+            <a:r>
+              <a:rPr sz="2000" b="1">
+                <a:solidFill>
+                  <a:srgbClr val="FFFFFF"/>
+                </a:solidFill>
+                <a:latin typeface="Cambria"/>
+              </a:rPr>
+              <a:t>MM</a:t>
+            </a:r>
+          </a:p>
+        </p:txBody>
+      </p:sp>
+      <p:sp>
+        <p:nvSpPr>
+          <p:cNvPr id="14" name="TextBox 11"/>
+          <p:cNvSpPr txBox="1"/>
+          <p:nvPr/>
+        </p:nvSpPr>
+        <p:spPr>
+          <a:xfrm>
+            <a:off x="3714750" y="3383280"/>
+            <a:ext cx="2023110" cy="365760"/>
+          </a:xfrm>
+          <a:prstGeom prst="rect">
+            <a:avLst/>
+          </a:prstGeom>
+          <a:noFill/>
+        </p:spPr>
+        <p:txBody>
+          <a:bodyPr wrap="square" lIns="0" rIns="0" tIns="0" bIns="0" anchor="t">
+            <a:spAutoFit/>
+          </a:bodyPr>
+          <a:lstStyle/>
+          <a:p>
+            <a:pPr algn="l"/>
+            <a:r>
+              <a:rPr sz="1600" b="1" i="0">
+                <a:solidFill>
+                  <a:srgbClr val="FFFFFF"/>
+                </a:solidFill>
+                <a:latin typeface="Cambria"/>
+              </a:rPr>
+              <a:t>Murali Madhav C</a:t>
+            </a:r>
+          </a:p>
+        </p:txBody>
+      </p:sp>
+      <p:sp>
+        <p:nvSpPr>
+          <p:cNvPr id="15" name="TextBox 23"/>
+          <p:cNvSpPr txBox="1"/>
+          <p:nvPr/>
+        </p:nvSpPr>
+        <p:spPr>
+          <a:xfrm>
+            <a:off x="3714750" y="3886200"/>
+            <a:ext cx="2023110" cy="228600"/>
+          </a:xfrm>
+          <a:prstGeom prst="rect">
+            <a:avLst/>
+          </a:prstGeom>
+          <a:noFill/>
+        </p:spPr>
+        <p:txBody>
+          <a:bodyPr wrap="square" lIns="0" rIns="0" tIns="0" bIns="0" anchor="t">
+            <a:spAutoFit/>
+          </a:bodyPr>
+          <a:lstStyle/>
+          <a:p>
+            <a:pPr algn="l"/>
+            <a:r>
+              <a:rPr sz="1100" b="1" i="0">
+                <a:solidFill>
+                  <a:srgbClr val="2EA79B"/>
+                </a:solidFill>
+                <a:latin typeface="Calibri"/>
+              </a:rPr>
+              <a:t>ROLE</a:t>
+            </a:r>
+          </a:p>
+        </p:txBody>
+      </p:sp>
+      <p:sp>
+        <p:nvSpPr>
+          <p:cNvPr id="16" name="TextBox 12"/>
+          <p:cNvSpPr txBox="1"/>
+          <p:nvPr/>
+        </p:nvSpPr>
+        <p:spPr>
+          <a:xfrm>
+            <a:off x="3714750" y="4160520"/>
+            <a:ext cx="2023110" cy="457200"/>
+          </a:xfrm>
+          <a:prstGeom prst="rect">
+            <a:avLst/>
+          </a:prstGeom>
+          <a:noFill/>
+        </p:spPr>
+        <p:txBody>
+          <a:bodyPr wrap="square" lIns="0" rIns="0" tIns="0" bIns="0" anchor="t">
+            <a:spAutoFit/>
+          </a:bodyPr>
+          <a:lstStyle/>
+          <a:p>
+            <a:pPr algn="l"/>
+            <a:r>
+              <a:rPr sz="1400" b="0" i="0">
+                <a:solidFill>
+                  <a:srgbClr val="D5E6EA"/>
+                </a:solidFill>
+                <a:latin typeface="Calibri"/>
+              </a:rPr>
+              <a:t>Code (notebook, scripts)</a:t>
+            </a:r>
+          </a:p>
+        </p:txBody>
+      </p:sp>
+      <p:sp>
+        <p:nvSpPr>
+          <p:cNvPr id="17" name="Rounded Rectangle 8"/>
+          <p:cNvSpPr/>
+          <p:nvPr/>
+        </p:nvSpPr>
+        <p:spPr>
+          <a:xfrm>
+            <a:off x="6195060" y="2011680"/>
+            <a:ext cx="2571750" cy="2743200"/>
+          </a:xfrm>
+          <a:prstGeom prst="roundRect">
+            <a:avLst>
+              <a:gd name="adj" fmla="val 6000"/>
+            </a:avLst>
+          </a:prstGeom>
+          <a:solidFill>
+            <a:srgbClr val="15455A"/>
+          </a:solidFill>
+          <a:ln w="12700">
+            <a:solidFill>
+              <a:srgbClr val="0E6274"/>
+            </a:solidFill>
+          </a:ln>
+          <a:effectLst/>
+        </p:spPr>
+        <p:style>
+          <a:lnRef idx="1">
+            <a:schemeClr val="accent1"/>
+          </a:lnRef>
+          <a:fillRef idx="3">
+            <a:schemeClr val="accent1"/>
+          </a:fillRef>
+          <a:effectRef idx="2">
+            <a:schemeClr val="accent1"/>
+          </a:effectRef>
+          <a:fontRef idx="minor">
+            <a:schemeClr val="lt1"/>
+          </a:fontRef>
+        </p:style>
+        <p:txBody>
+          <a:bodyPr rtlCol="0" anchor="ctr"/>
+          <a:lstStyle/>
+          <a:p/>
+        </p:txBody>
+      </p:sp>
+      <p:sp>
+        <p:nvSpPr>
+          <p:cNvPr id="18" name="Oval 9"/>
+          <p:cNvSpPr/>
+          <p:nvPr/>
+        </p:nvSpPr>
+        <p:spPr>
+          <a:xfrm>
+            <a:off x="6469380" y="2331720"/>
+            <a:ext cx="822960" cy="822960"/>
+          </a:xfrm>
+          <a:prstGeom prst="ellipse">
+            <a:avLst/>
+          </a:prstGeom>
+          <a:solidFill>
+            <a:srgbClr val="D99A00"/>
+          </a:solidFill>
+          <a:ln>
+            <a:noFill/>
+          </a:ln>
+          <a:effectLst/>
+        </p:spPr>
+        <p:style>
+          <a:lnRef idx="1">
+            <a:schemeClr val="accent1"/>
+          </a:lnRef>
+          <a:fillRef idx="3">
+            <a:schemeClr val="accent1"/>
+          </a:fillRef>
+          <a:effectRef idx="2">
+            <a:schemeClr val="accent1"/>
+          </a:effectRef>
+          <a:fontRef idx="minor">
+            <a:schemeClr val="lt1"/>
+          </a:fontRef>
+        </p:style>
+        <p:txBody>
+          <a:bodyPr rtlCol="0" anchor="ctr" lIns="0" rIns="0" tIns="0" bIns="0"/>
+          <a:lstStyle/>
+          <a:p>
+            <a:pPr algn="ctr"/>
+            <a:r>
+              <a:rPr sz="2000" b="1">
+                <a:solidFill>
+                  <a:srgbClr val="FFFFFF"/>
+                </a:solidFill>
+                <a:latin typeface="Cambria"/>
+              </a:rPr>
+              <a:t>RY</a:t>
+            </a:r>
+          </a:p>
+        </p:txBody>
+      </p:sp>
+      <p:sp>
+        <p:nvSpPr>
+          <p:cNvPr id="19" name="TextBox 11"/>
+          <p:cNvSpPr txBox="1"/>
+          <p:nvPr/>
+        </p:nvSpPr>
+        <p:spPr>
+          <a:xfrm>
+            <a:off x="6469380" y="3383280"/>
+            <a:ext cx="2023110" cy="365760"/>
+          </a:xfrm>
+          <a:prstGeom prst="rect">
+            <a:avLst/>
+          </a:prstGeom>
+          <a:noFill/>
+        </p:spPr>
+        <p:txBody>
+          <a:bodyPr wrap="square" lIns="0" rIns="0" tIns="0" bIns="0" anchor="t">
+            <a:spAutoFit/>
+          </a:bodyPr>
+          <a:lstStyle/>
+          <a:p>
+            <a:pPr algn="l"/>
+            <a:r>
+              <a:rPr sz="1600" b="1" i="0">
+                <a:solidFill>
+                  <a:srgbClr val="FFFFFF"/>
+                </a:solidFill>
+                <a:latin typeface="Cambria"/>
+              </a:rPr>
+              <a:t>Ravi Yadav</a:t>
+            </a:r>
+          </a:p>
+        </p:txBody>
+      </p:sp>
+      <p:sp>
+        <p:nvSpPr>
+          <p:cNvPr id="20" name="TextBox 23"/>
+          <p:cNvSpPr txBox="1"/>
+          <p:nvPr/>
+        </p:nvSpPr>
+        <p:spPr>
+          <a:xfrm>
+            <a:off x="6469380" y="3886200"/>
+            <a:ext cx="2023110" cy="228600"/>
+          </a:xfrm>
+          <a:prstGeom prst="rect">
+            <a:avLst/>
+          </a:prstGeom>
+          <a:noFill/>
+        </p:spPr>
+        <p:txBody>
+          <a:bodyPr wrap="square" lIns="0" rIns="0" tIns="0" bIns="0" anchor="t">
+            <a:spAutoFit/>
+          </a:bodyPr>
+          <a:lstStyle/>
+          <a:p>
+            <a:pPr algn="l"/>
+            <a:r>
+              <a:rPr sz="1100" b="1" i="0">
+                <a:solidFill>
+                  <a:srgbClr val="2EA79B"/>
+                </a:solidFill>
+                <a:latin typeface="Calibri"/>
+              </a:rPr>
+              <a:t>ROLE</a:t>
+            </a:r>
+          </a:p>
+        </p:txBody>
+      </p:sp>
+      <p:sp>
+        <p:nvSpPr>
+          <p:cNvPr id="21" name="TextBox 12"/>
+          <p:cNvSpPr txBox="1"/>
+          <p:nvPr/>
+        </p:nvSpPr>
+        <p:spPr>
+          <a:xfrm>
+            <a:off x="6469380" y="4160520"/>
+            <a:ext cx="2023110" cy="457200"/>
+          </a:xfrm>
+          <a:prstGeom prst="rect">
+            <a:avLst/>
+          </a:prstGeom>
+          <a:noFill/>
+        </p:spPr>
+        <p:txBody>
+          <a:bodyPr wrap="square" lIns="0" rIns="0" tIns="0" bIns="0" anchor="t">
+            <a:spAutoFit/>
+          </a:bodyPr>
+          <a:lstStyle/>
+          <a:p>
+            <a:pPr algn="l"/>
+            <a:r>
+              <a:rPr sz="1400" b="0" i="0">
+                <a:solidFill>
+                  <a:srgbClr val="D5E6EA"/>
+                </a:solidFill>
+                <a:latin typeface="Calibri"/>
+              </a:rPr>
+              <a:t>Slides</a:t>
+            </a:r>
+          </a:p>
+        </p:txBody>
+      </p:sp>
+      <p:sp>
+        <p:nvSpPr>
+          <p:cNvPr id="22" name="Rounded Rectangle 8"/>
+          <p:cNvSpPr/>
+          <p:nvPr/>
+        </p:nvSpPr>
+        <p:spPr>
+          <a:xfrm>
+            <a:off x="8949690" y="2011680"/>
+            <a:ext cx="2571750" cy="2743200"/>
+          </a:xfrm>
+          <a:prstGeom prst="roundRect">
+            <a:avLst>
+              <a:gd name="adj" fmla="val 6000"/>
+            </a:avLst>
+          </a:prstGeom>
+          <a:solidFill>
+            <a:srgbClr val="15455A"/>
+          </a:solidFill>
+          <a:ln w="12700">
+            <a:solidFill>
+              <a:srgbClr val="0E6274"/>
+            </a:solidFill>
+          </a:ln>
+          <a:effectLst/>
+        </p:spPr>
+        <p:style>
+          <a:lnRef idx="1">
+            <a:schemeClr val="accent1"/>
+          </a:lnRef>
+          <a:fillRef idx="3">
+            <a:schemeClr val="accent1"/>
+          </a:fillRef>
+          <a:effectRef idx="2">
+            <a:schemeClr val="accent1"/>
+          </a:effectRef>
+          <a:fontRef idx="minor">
+            <a:schemeClr val="lt1"/>
+          </a:fontRef>
+        </p:style>
+        <p:txBody>
+          <a:bodyPr rtlCol="0" anchor="ctr"/>
+          <a:lstStyle/>
+          <a:p/>
+        </p:txBody>
+      </p:sp>
+      <p:sp>
+        <p:nvSpPr>
+          <p:cNvPr id="23" name="Oval 9"/>
+          <p:cNvSpPr/>
+          <p:nvPr/>
+        </p:nvSpPr>
+        <p:spPr>
+          <a:xfrm>
+            <a:off x="9224010" y="2331720"/>
+            <a:ext cx="822960" cy="822960"/>
+          </a:xfrm>
+          <a:prstGeom prst="ellipse">
+            <a:avLst/>
+          </a:prstGeom>
+          <a:solidFill>
+            <a:srgbClr val="2EA79B"/>
+          </a:solidFill>
+          <a:ln>
+            <a:noFill/>
+          </a:ln>
+          <a:effectLst/>
+        </p:spPr>
+        <p:style>
+          <a:lnRef idx="1">
+            <a:schemeClr val="accent1"/>
+          </a:lnRef>
+          <a:fillRef idx="3">
+            <a:schemeClr val="accent1"/>
+          </a:fillRef>
+          <a:effectRef idx="2">
+            <a:schemeClr val="accent1"/>
+          </a:effectRef>
+          <a:fontRef idx="minor">
+            <a:schemeClr val="lt1"/>
+          </a:fontRef>
+        </p:style>
+        <p:txBody>
+          <a:bodyPr rtlCol="0" anchor="ctr" lIns="0" rIns="0" tIns="0" bIns="0"/>
+          <a:lstStyle/>
+          <a:p>
+            <a:pPr algn="ctr"/>
+            <a:r>
+              <a:rPr sz="2000" b="1">
+                <a:solidFill>
+                  <a:srgbClr val="FFFFFF"/>
+                </a:solidFill>
+                <a:latin typeface="Cambria"/>
+              </a:rPr>
+              <a:t>PJ</a:t>
+            </a:r>
+          </a:p>
+        </p:txBody>
+      </p:sp>
+      <p:sp>
+        <p:nvSpPr>
+          <p:cNvPr id="24" name="TextBox 11"/>
+          <p:cNvSpPr txBox="1"/>
+          <p:nvPr/>
+        </p:nvSpPr>
+        <p:spPr>
+          <a:xfrm>
+            <a:off x="9224010" y="3383280"/>
+            <a:ext cx="2023110" cy="365760"/>
+          </a:xfrm>
+          <a:prstGeom prst="rect">
+            <a:avLst/>
+          </a:prstGeom>
+          <a:noFill/>
+        </p:spPr>
+        <p:txBody>
+          <a:bodyPr wrap="square" lIns="0" rIns="0" tIns="0" bIns="0" anchor="t">
+            <a:spAutoFit/>
+          </a:bodyPr>
+          <a:lstStyle/>
+          <a:p>
+            <a:pPr algn="l"/>
+            <a:r>
+              <a:rPr sz="1600" b="1" i="0">
+                <a:solidFill>
+                  <a:srgbClr val="FFFFFF"/>
+                </a:solidFill>
+                <a:latin typeface="Cambria"/>
+              </a:rPr>
+              <a:t>Pugazhendhi J</a:t>
+            </a:r>
+          </a:p>
+        </p:txBody>
+      </p:sp>
+      <p:sp>
+        <p:nvSpPr>
+          <p:cNvPr id="25" name="TextBox 23"/>
+          <p:cNvSpPr txBox="1"/>
+          <p:nvPr/>
+        </p:nvSpPr>
+        <p:spPr>
+          <a:xfrm>
+            <a:off x="9224010" y="3886200"/>
+            <a:ext cx="2023110" cy="228600"/>
+          </a:xfrm>
+          <a:prstGeom prst="rect">
+            <a:avLst/>
+          </a:prstGeom>
+          <a:noFill/>
+        </p:spPr>
+        <p:txBody>
+          <a:bodyPr wrap="square" lIns="0" rIns="0" tIns="0" bIns="0" anchor="t">
+            <a:spAutoFit/>
+          </a:bodyPr>
+          <a:lstStyle/>
+          <a:p>
+            <a:pPr algn="l"/>
+            <a:r>
+              <a:rPr sz="1100" b="1" i="0">
+                <a:solidFill>
+                  <a:srgbClr val="2EA79B"/>
+                </a:solidFill>
+                <a:latin typeface="Calibri"/>
+              </a:rPr>
+              <a:t>ROLE</a:t>
+            </a:r>
+          </a:p>
+        </p:txBody>
+      </p:sp>
+      <p:sp>
+        <p:nvSpPr>
+          <p:cNvPr id="26" name="TextBox 12"/>
+          <p:cNvSpPr txBox="1"/>
+          <p:nvPr/>
+        </p:nvSpPr>
+        <p:spPr>
+          <a:xfrm>
+            <a:off x="9224010" y="4160520"/>
+            <a:ext cx="2023110" cy="457200"/>
+          </a:xfrm>
+          <a:prstGeom prst="rect">
+            <a:avLst/>
+          </a:prstGeom>
+          <a:noFill/>
+        </p:spPr>
+        <p:txBody>
+          <a:bodyPr wrap="square" lIns="0" rIns="0" tIns="0" bIns="0" anchor="t">
+            <a:spAutoFit/>
+          </a:bodyPr>
+          <a:lstStyle/>
+          <a:p>
+            <a:pPr algn="l"/>
+            <a:r>
+              <a:rPr sz="1400" b="0" i="0">
+                <a:solidFill>
+                  <a:srgbClr val="D5E6EA"/>
+                </a:solidFill>
+                <a:latin typeface="Calibri"/>
+              </a:rPr>
+              <a:t>Report</a:t>
+            </a:r>
+          </a:p>
+        </p:txBody>
+      </p:sp>
+      <p:sp>
+        <p:nvSpPr>
+          <p:cNvPr id="27" name="TextBox 23"/>
+          <p:cNvSpPr txBox="1"/>
+          <p:nvPr/>
+        </p:nvSpPr>
+        <p:spPr>
+          <a:xfrm>
+            <a:off x="685800" y="5212080"/>
+            <a:ext cx="10058400" cy="365760"/>
+          </a:xfrm>
+          <a:prstGeom prst="rect">
+            <a:avLst/>
+          </a:prstGeom>
+          <a:noFill/>
+        </p:spPr>
+        <p:txBody>
+          <a:bodyPr wrap="square" lIns="0" rIns="0" tIns="0" bIns="0" anchor="t">
+            <a:spAutoFit/>
+          </a:bodyPr>
+          <a:lstStyle/>
+          <a:p>
+            <a:pPr algn="l"/>
+            <a:r>
+              <a:rPr sz="1400" b="1" i="0">
+                <a:solidFill>
+                  <a:srgbClr val="2EA79B"/>
+                </a:solidFill>
+                <a:latin typeface="Calibri"/>
+              </a:rPr>
+              <a:t>Code, results &amp; slides:  </a:t>
+            </a:r>
+            <a:r>
+              <a:rPr sz="1400" b="0" i="0">
+                <a:solidFill>
+                  <a:srgbClr val="CFE3E8"/>
+                </a:solidFill>
+                <a:latin typeface="Calibri"/>
+              </a:rPr>
+              <a:t>github.com/amathziah/malaria-detection</a:t>
+            </a:r>
           </a:p>
         </p:txBody>
       </p:sp>
@@ -21259,7 +22548,7 @@
                 <a:ea typeface="Calibri" pitchFamily="34" charset="-122"/>
                 <a:cs typeface="Calibri" pitchFamily="34" charset="-120"/>
               </a:rPr>
-              <a:t>3</a:t>
+              <a:t>4</a:t>
             </a:r>
             <a:endParaRPr lang="en-US" sz="1000" dirty="0"/>
           </a:p>
@@ -21477,6 +22766,10 @@
             </a:outerShdw>
           </a:effectLst>
         </p:spPr>
+        <p:txBody>
+          <a:bodyPr/>
+          <a:p/>
+        </p:txBody>
       </p:sp>
       <p:sp>
         <p:nvSpPr>
@@ -21592,6 +22885,10 @@
             </a:outerShdw>
           </a:effectLst>
         </p:spPr>
+        <p:txBody>
+          <a:bodyPr/>
+          <a:p/>
+        </p:txBody>
       </p:sp>
       <p:sp>
         <p:nvSpPr>
@@ -21707,6 +23004,10 @@
             </a:outerShdw>
           </a:effectLst>
         </p:spPr>
+        <p:txBody>
+          <a:bodyPr/>
+          <a:p/>
+        </p:txBody>
       </p:sp>
       <p:sp>
         <p:nvSpPr>
@@ -21815,6 +23116,10 @@
             <a:prstDash val="solid"/>
           </a:ln>
         </p:spPr>
+        <p:txBody>
+          <a:bodyPr/>
+          <a:p/>
+        </p:txBody>
       </p:sp>
       <p:sp>
         <p:nvSpPr>
@@ -21835,6 +23140,10 @@
           </a:solidFill>
           <a:ln/>
         </p:spPr>
+        <p:txBody>
+          <a:bodyPr/>
+          <a:p/>
+        </p:txBody>
       </p:sp>
       <p:pic>
         <p:nvPicPr>
@@ -22025,6 +23334,10 @@
             </a:outerShdw>
           </a:effectLst>
         </p:spPr>
+        <p:txBody>
+          <a:bodyPr/>
+          <a:p/>
+        </p:txBody>
       </p:sp>
       <p:sp>
         <p:nvSpPr>
@@ -22213,6 +23526,10 @@
             <a:prstDash val="solid"/>
           </a:ln>
         </p:spPr>
+        <p:txBody>
+          <a:bodyPr/>
+          <a:p/>
+        </p:txBody>
       </p:sp>
       <p:sp>
         <p:nvSpPr>
@@ -22362,7 +23679,7 @@
                 <a:ea typeface="Calibri" pitchFamily="34" charset="-122"/>
                 <a:cs typeface="Calibri" pitchFamily="34" charset="-120"/>
               </a:rPr>
-              <a:t>4</a:t>
+              <a:t>5</a:t>
             </a:r>
             <a:endParaRPr lang="en-US" sz="1000" dirty="0"/>
           </a:p>
@@ -22414,6 +23731,10 @@
           </a:solidFill>
           <a:ln/>
         </p:spPr>
+        <p:txBody>
+          <a:bodyPr/>
+          <a:p/>
+        </p:txBody>
       </p:sp>
       <p:sp>
         <p:nvSpPr>
@@ -22436,6 +23757,10 @@
           </a:solidFill>
           <a:ln/>
         </p:spPr>
+        <p:txBody>
+          <a:bodyPr/>
+          <a:p/>
+        </p:txBody>
       </p:sp>
       <p:sp>
         <p:nvSpPr>
@@ -22458,6 +23783,10 @@
           </a:solidFill>
           <a:ln/>
         </p:spPr>
+        <p:txBody>
+          <a:bodyPr/>
+          <a:p/>
+        </p:txBody>
       </p:sp>
       <p:sp>
         <p:nvSpPr>
@@ -22559,6 +23888,10 @@
             <a:prstDash val="solid"/>
           </a:ln>
         </p:spPr>
+        <p:txBody>
+          <a:bodyPr/>
+          <a:p/>
+        </p:txBody>
       </p:sp>
       <p:sp>
         <p:nvSpPr>
@@ -22680,6 +24013,10 @@
           </a:solidFill>
           <a:ln/>
         </p:spPr>
+        <p:txBody>
+          <a:bodyPr/>
+          <a:p/>
+        </p:txBody>
       </p:sp>
       <p:pic>
         <p:nvPicPr>
@@ -22726,6 +24063,10 @@
             <a:prstDash val="solid"/>
           </a:ln>
         </p:spPr>
+        <p:txBody>
+          <a:bodyPr/>
+          <a:p/>
+        </p:txBody>
       </p:sp>
       <p:sp>
         <p:nvSpPr>
@@ -22889,6 +24230,10 @@
           </a:solidFill>
           <a:ln/>
         </p:spPr>
+        <p:txBody>
+          <a:bodyPr/>
+          <a:p/>
+        </p:txBody>
       </p:sp>
       <p:pic>
         <p:nvPicPr>
@@ -22935,6 +24280,10 @@
             <a:prstDash val="solid"/>
           </a:ln>
         </p:spPr>
+        <p:txBody>
+          <a:bodyPr/>
+          <a:p/>
+        </p:txBody>
       </p:sp>
       <p:sp>
         <p:nvSpPr>
@@ -23098,6 +24447,10 @@
           </a:solidFill>
           <a:ln/>
         </p:spPr>
+        <p:txBody>
+          <a:bodyPr/>
+          <a:p/>
+        </p:txBody>
       </p:sp>
       <p:pic>
         <p:nvPicPr>
@@ -23144,6 +24497,10 @@
             <a:prstDash val="solid"/>
           </a:ln>
         </p:spPr>
+        <p:txBody>
+          <a:bodyPr/>
+          <a:p/>
+        </p:txBody>
       </p:sp>
       <p:sp>
         <p:nvSpPr>
@@ -23307,6 +24664,10 @@
           </a:solidFill>
           <a:ln/>
         </p:spPr>
+        <p:txBody>
+          <a:bodyPr/>
+          <a:p/>
+        </p:txBody>
       </p:sp>
       <p:pic>
         <p:nvPicPr>
@@ -23353,6 +24714,10 @@
             <a:prstDash val="solid"/>
           </a:ln>
         </p:spPr>
+        <p:txBody>
+          <a:bodyPr/>
+          <a:p/>
+        </p:txBody>
       </p:sp>
       <p:sp>
         <p:nvSpPr>
@@ -23516,6 +24881,10 @@
           </a:solidFill>
           <a:ln/>
         </p:spPr>
+        <p:txBody>
+          <a:bodyPr/>
+          <a:p/>
+        </p:txBody>
       </p:sp>
       <p:pic>
         <p:nvPicPr>
@@ -23562,6 +24931,10 @@
             <a:prstDash val="solid"/>
           </a:ln>
         </p:spPr>
+        <p:txBody>
+          <a:bodyPr/>
+          <a:p/>
+        </p:txBody>
       </p:sp>
       <p:sp>
         <p:nvSpPr>
@@ -23800,6 +25173,10 @@
             </a:outerShdw>
           </a:effectLst>
         </p:spPr>
+        <p:txBody>
+          <a:bodyPr/>
+          <a:p/>
+        </p:txBody>
       </p:sp>
       <p:sp>
         <p:nvSpPr>
@@ -23820,6 +25197,10 @@
           </a:solidFill>
           <a:ln/>
         </p:spPr>
+        <p:txBody>
+          <a:bodyPr/>
+          <a:p/>
+        </p:txBody>
       </p:sp>
       <p:pic>
         <p:nvPicPr>
@@ -23952,6 +25333,10 @@
             <a:prstDash val="solid"/>
           </a:ln>
         </p:spPr>
+        <p:txBody>
+          <a:bodyPr/>
+          <a:p/>
+        </p:txBody>
       </p:sp>
       <p:sp>
         <p:nvSpPr>
@@ -24057,6 +25442,10 @@
             <a:prstDash val="solid"/>
           </a:ln>
         </p:spPr>
+        <p:txBody>
+          <a:bodyPr/>
+          <a:p/>
+        </p:txBody>
       </p:sp>
       <p:sp>
         <p:nvSpPr>
@@ -24169,6 +25558,10 @@
             </a:outerShdw>
           </a:effectLst>
         </p:spPr>
+        <p:txBody>
+          <a:bodyPr/>
+          <a:p/>
+        </p:txBody>
       </p:sp>
       <p:sp>
         <p:nvSpPr>
@@ -24189,6 +25582,10 @@
           </a:solidFill>
           <a:ln/>
         </p:spPr>
+        <p:txBody>
+          <a:bodyPr/>
+          <a:p/>
+        </p:txBody>
       </p:sp>
       <p:pic>
         <p:nvPicPr>
@@ -24321,6 +25718,10 @@
             <a:prstDash val="solid"/>
           </a:ln>
         </p:spPr>
+        <p:txBody>
+          <a:bodyPr/>
+          <a:p/>
+        </p:txBody>
       </p:sp>
       <p:sp>
         <p:nvSpPr>
@@ -24387,6 +25788,10 @@
             <a:prstDash val="solid"/>
           </a:ln>
         </p:spPr>
+        <p:txBody>
+          <a:bodyPr/>
+          <a:p/>
+        </p:txBody>
       </p:sp>
       <p:sp>
         <p:nvSpPr>
@@ -24453,6 +25858,10 @@
             <a:prstDash val="solid"/>
           </a:ln>
         </p:spPr>
+        <p:txBody>
+          <a:bodyPr/>
+          <a:p/>
+        </p:txBody>
       </p:sp>
       <p:sp>
         <p:nvSpPr>
@@ -24519,6 +25928,10 @@
             <a:prstDash val="solid"/>
           </a:ln>
         </p:spPr>
+        <p:txBody>
+          <a:bodyPr/>
+          <a:p/>
+        </p:txBody>
       </p:sp>
       <p:sp>
         <p:nvSpPr>
@@ -24585,6 +25998,10 @@
             <a:prstDash val="solid"/>
           </a:ln>
         </p:spPr>
+        <p:txBody>
+          <a:bodyPr/>
+          <a:p/>
+        </p:txBody>
       </p:sp>
       <p:sp>
         <p:nvSpPr>
@@ -24685,6 +26102,10 @@
           </a:solidFill>
           <a:ln/>
         </p:spPr>
+        <p:txBody>
+          <a:bodyPr/>
+          <a:p/>
+        </p:txBody>
       </p:sp>
       <p:sp>
         <p:nvSpPr>
@@ -24705,6 +26126,10 @@
           </a:solidFill>
           <a:ln/>
         </p:spPr>
+        <p:txBody>
+          <a:bodyPr/>
+          <a:p/>
+        </p:txBody>
       </p:sp>
       <p:pic>
         <p:nvPicPr>
@@ -24900,7 +26325,7 @@
                 <a:ea typeface="Calibri" pitchFamily="34" charset="-122"/>
                 <a:cs typeface="Calibri" pitchFamily="34" charset="-120"/>
               </a:rPr>
-              <a:t>6</a:t>
+              <a:t>7</a:t>
             </a:r>
             <a:endParaRPr lang="en-US" sz="1000" dirty="0"/>
           </a:p>
@@ -25118,6 +26543,10 @@
             </a:outerShdw>
           </a:effectLst>
         </p:spPr>
+        <p:txBody>
+          <a:bodyPr/>
+          <a:p/>
+        </p:txBody>
       </p:sp>
       <p:sp>
         <p:nvSpPr>
@@ -25138,6 +26567,10 @@
           </a:solidFill>
           <a:ln/>
         </p:spPr>
+        <p:txBody>
+          <a:bodyPr/>
+          <a:p/>
+        </p:txBody>
       </p:sp>
       <p:pic>
         <p:nvPicPr>
@@ -25350,6 +26783,10 @@
             </a:outerShdw>
           </a:effectLst>
         </p:spPr>
+        <p:txBody>
+          <a:bodyPr/>
+          <a:p/>
+        </p:txBody>
       </p:sp>
       <p:sp>
         <p:nvSpPr>
@@ -25370,6 +26807,10 @@
           </a:solidFill>
           <a:ln/>
         </p:spPr>
+        <p:txBody>
+          <a:bodyPr/>
+          <a:p/>
+        </p:txBody>
       </p:sp>
       <p:pic>
         <p:nvPicPr>
@@ -25575,6 +27016,10 @@
             <a:prstDash val="solid"/>
           </a:ln>
         </p:spPr>
+        <p:txBody>
+          <a:bodyPr/>
+          <a:p/>
+        </p:txBody>
       </p:sp>
       <p:sp>
         <p:nvSpPr>
@@ -25595,6 +27040,10 @@
           </a:solidFill>
           <a:ln/>
         </p:spPr>
+        <p:txBody>
+          <a:bodyPr/>
+          <a:p/>
+        </p:txBody>
       </p:sp>
       <p:pic>
         <p:nvPicPr>
@@ -25751,7 +27200,7 @@
                 <a:ea typeface="Calibri" pitchFamily="34" charset="-122"/>
                 <a:cs typeface="Calibri" pitchFamily="34" charset="-120"/>
               </a:rPr>
-              <a:t>7</a:t>
+              <a:t>8</a:t>
             </a:r>
             <a:endParaRPr lang="en-US" sz="1000" dirty="0"/>
           </a:p>
@@ -25935,6 +27384,10 @@
             </a:outerShdw>
           </a:effectLst>
         </p:spPr>
+        <p:txBody>
+          <a:bodyPr/>
+          <a:p/>
+        </p:txBody>
       </p:sp>
       <p:sp>
         <p:nvSpPr>
@@ -25955,6 +27408,10 @@
           </a:solidFill>
           <a:ln/>
         </p:spPr>
+        <p:txBody>
+          <a:bodyPr/>
+          <a:p/>
+        </p:txBody>
       </p:sp>
       <p:pic>
         <p:nvPicPr>
@@ -26337,6 +27794,10 @@
             </a:outerShdw>
           </a:effectLst>
         </p:spPr>
+        <p:txBody>
+          <a:bodyPr/>
+          <a:p/>
+        </p:txBody>
       </p:sp>
       <p:sp>
         <p:nvSpPr>
@@ -26357,6 +27818,10 @@
           </a:solidFill>
           <a:ln/>
         </p:spPr>
+        <p:txBody>
+          <a:bodyPr/>
+          <a:p/>
+        </p:txBody>
       </p:sp>
       <p:pic>
         <p:nvPicPr>
@@ -26739,6 +28204,10 @@
             </a:outerShdw>
           </a:effectLst>
         </p:spPr>
+        <p:txBody>
+          <a:bodyPr/>
+          <a:p/>
+        </p:txBody>
       </p:sp>
       <p:sp>
         <p:nvSpPr>
@@ -26759,6 +28228,10 @@
           </a:solidFill>
           <a:ln/>
         </p:spPr>
+        <p:txBody>
+          <a:bodyPr/>
+          <a:p/>
+        </p:txBody>
       </p:sp>
       <p:pic>
         <p:nvPicPr>
@@ -27180,7 +28653,7 @@
                 <a:ea typeface="Calibri" pitchFamily="34" charset="-122"/>
                 <a:cs typeface="Calibri" pitchFamily="34" charset="-120"/>
               </a:rPr>
-              <a:t>8</a:t>
+              <a:t>9</a:t>
             </a:r>
             <a:endParaRPr lang="en-US" sz="1000" dirty="0"/>
           </a:p>
@@ -27322,6 +28795,10 @@
             </a:outerShdw>
           </a:effectLst>
         </p:spPr>
+        <p:txBody>
+          <a:bodyPr/>
+          <a:p/>
+        </p:txBody>
       </p:sp>
       <p:sp>
         <p:nvSpPr>
@@ -27342,6 +28819,10 @@
           </a:solidFill>
           <a:ln/>
         </p:spPr>
+        <p:txBody>
+          <a:bodyPr/>
+          <a:p/>
+        </p:txBody>
       </p:sp>
       <p:pic>
         <p:nvPicPr>
@@ -27581,6 +29062,10 @@
             <a:prstDash val="solid"/>
           </a:ln>
         </p:spPr>
+        <p:txBody>
+          <a:bodyPr/>
+          <a:p/>
+        </p:txBody>
       </p:sp>
       <p:sp>
         <p:nvSpPr>
@@ -27814,6 +29299,10 @@
             </a:outerShdw>
           </a:effectLst>
         </p:spPr>
+        <p:txBody>
+          <a:bodyPr/>
+          <a:p/>
+        </p:txBody>
       </p:sp>
       <p:sp>
         <p:nvSpPr>
@@ -27834,6 +29323,10 @@
           </a:solidFill>
           <a:ln/>
         </p:spPr>
+        <p:txBody>
+          <a:bodyPr/>
+          <a:p/>
+        </p:txBody>
       </p:sp>
       <p:pic>
         <p:nvPicPr>
@@ -27956,6 +29449,10 @@
           </a:solidFill>
           <a:ln/>
         </p:spPr>
+        <p:txBody>
+          <a:bodyPr/>
+          <a:p/>
+        </p:txBody>
       </p:sp>
       <p:sp>
         <p:nvSpPr>
@@ -28071,6 +29568,10 @@
             <a:prstDash val="solid"/>
           </a:ln>
         </p:spPr>
+        <p:txBody>
+          <a:bodyPr/>
+          <a:p/>
+        </p:txBody>
       </p:sp>
       <p:sp>
         <p:nvSpPr>
@@ -28091,6 +29592,10 @@
           </a:solidFill>
           <a:ln/>
         </p:spPr>
+        <p:txBody>
+          <a:bodyPr/>
+          <a:p/>
+        </p:txBody>
       </p:sp>
       <p:sp>
         <p:nvSpPr>
@@ -28206,6 +29711,10 @@
             <a:prstDash val="solid"/>
           </a:ln>
         </p:spPr>
+        <p:txBody>
+          <a:bodyPr/>
+          <a:p/>
+        </p:txBody>
       </p:sp>
       <p:sp>
         <p:nvSpPr>
@@ -28226,6 +29735,10 @@
           </a:solidFill>
           <a:ln/>
         </p:spPr>
+        <p:txBody>
+          <a:bodyPr/>
+          <a:p/>
+        </p:txBody>
       </p:sp>
       <p:sp>
         <p:nvSpPr>
@@ -28341,6 +29854,10 @@
             <a:prstDash val="solid"/>
           </a:ln>
         </p:spPr>
+        <p:txBody>
+          <a:bodyPr/>
+          <a:p/>
+        </p:txBody>
       </p:sp>
       <p:sp>
         <p:nvSpPr>
@@ -28361,6 +29878,10 @@
           </a:solidFill>
           <a:ln/>
         </p:spPr>
+        <p:txBody>
+          <a:bodyPr/>
+          <a:p/>
+        </p:txBody>
       </p:sp>
       <p:sp>
         <p:nvSpPr>
@@ -28476,6 +29997,10 @@
             <a:prstDash val="solid"/>
           </a:ln>
         </p:spPr>
+        <p:txBody>
+          <a:bodyPr/>
+          <a:p/>
+        </p:txBody>
       </p:sp>
       <p:sp>
         <p:nvSpPr>
@@ -28496,6 +30021,10 @@
           </a:solidFill>
           <a:ln/>
         </p:spPr>
+        <p:txBody>
+          <a:bodyPr/>
+          <a:p/>
+        </p:txBody>
       </p:sp>
       <p:sp>
         <p:nvSpPr>
@@ -28714,7 +30243,7 @@
                 <a:ea typeface="Calibri" pitchFamily="34" charset="-122"/>
                 <a:cs typeface="Calibri" pitchFamily="34" charset="-120"/>
               </a:rPr>
-              <a:t>9</a:t>
+              <a:t>10</a:t>
             </a:r>
             <a:endParaRPr lang="en-US" sz="1000" dirty="0"/>
           </a:p>

</xml_diff>

<commit_message>
Slides: speaker notes for results figures
</commit_message>
<xml_diff>
--- a/slides/Malaria_Phase2_Baseline_Hypothesis_filled.pptx
+++ b/slides/Malaria_Phase2_Baseline_Hypothesis_filled.pptx
@@ -1877,6 +1877,96 @@
           <a:p>
             <a:r>
               <a:t>How we will test the hypothesis next milestone. A0 is done: that's the reproduction. A1 removes leakage (H1). A2 adds stain normalisation on top (H2). A3 is a control showing that any gain is about generalising to new slides, not a general boost. We report recall and MCC alongside accuracy, as mean ± SD over folds. All of these are already built into the notebook as on/off switches. Our A0 baseline already shows why recall comes first: 96.81 % vs. the paper's 98.82 %, i.e. 44 missed infected cells on the test set.</a:t>
+            </a:r>
+          </a:p>
+        </p:txBody>
+      </p:sp>
+      <p:sp>
+        <p:nvSpPr>
+          <p:cNvPr id="4" name="Slide Number Placeholder 3"/>
+          <p:cNvSpPr>
+            <a:spLocks noGrp="1"/>
+          </p:cNvSpPr>
+          <p:nvPr>
+            <p:ph type="sldNum" idx="5" sz="quarter"/>
+          </p:nvPr>
+        </p:nvSpPr>
+        <p:spPr/>
+      </p:sp>
+    </p:spTree>
+  </p:cSld>
+  <p:clrMapOvr>
+    <a:masterClrMapping/>
+  </p:clrMapOvr>
+</p:notes>
+</file>
+
+<file path=ppt/notesSlides/notesSlide22.xml><?xml version="1.0" encoding="utf-8"?>
+<p:notes xmlns:a="http://schemas.openxmlformats.org/drawingml/2006/main" xmlns:p="http://schemas.openxmlformats.org/presentationml/2006/main" xmlns:r="http://schemas.openxmlformats.org/officeDocument/2006/relationships">
+  <p:cSld>
+    <p:spTree>
+      <p:nvGrpSpPr>
+        <p:cNvPr id="1" name=""/>
+        <p:cNvGrpSpPr/>
+        <p:nvPr/>
+      </p:nvGrpSpPr>
+      <p:grpSpPr>
+        <a:xfrm>
+          <a:off x="0" y="0"/>
+          <a:ext cx="0" cy="0"/>
+          <a:chOff x="0" y="0"/>
+          <a:chExt cx="0" cy="0"/>
+        </a:xfrm>
+      </p:grpSpPr>
+      <p:sp>
+        <p:nvSpPr>
+          <p:cNvPr id="2" name="Slide Image Placeholder 1"/>
+          <p:cNvSpPr>
+            <a:spLocks noGrp="1"/>
+          </p:cNvSpPr>
+          <p:nvPr>
+            <p:ph type="sldImg" idx="2"/>
+          </p:nvPr>
+        </p:nvSpPr>
+        <p:spPr/>
+      </p:sp>
+      <p:sp>
+        <p:nvSpPr>
+          <p:cNvPr id="3" name="Notes Placeholder 2"/>
+          <p:cNvSpPr>
+            <a:spLocks noGrp="1"/>
+          </p:cNvSpPr>
+          <p:nvPr>
+            <p:ph type="body" idx="3" sz="quarter"/>
+          </p:nvPr>
+        </p:nvSpPr>
+        <p:spPr/>
+        <p:txBody>
+          <a:bodyPr/>
+          <a:lstStyle/>
+          <a:p>
+            <a:r>
+              <a:t>This slide is just the A0 results as pictures, so you can see them instead of reading the table.</a:t>
+            </a:r>
+          </a:p>
+          <a:p>
+            <a:r>
+              <a:t>Left, paper vs. ours: light bars are what Marques et al. report, dark bars are our run. The axis starts at 94 %, so the gaps look bigger than they are. Mean fold accuracy is 0.32 pp lower and ensemble accuracy 0.72 pp lower, both inside our 1 pp target. Precision is actually a bit higher than the paper, ROC-AUC is the same (99.76 %). Recall is the one real gap: 96.81 % vs. 98.82 %.</a:t>
+            </a:r>
+          </a:p>
+          <a:p>
+            <a:r>
+              <a:t>Right, first panel, training curves: accuracy per epoch for each of our 3 folds, dashed is training and solid is validation. Validation flattens out after a few epochs, which is why early stopping ended each fold after 9 or 10 epochs. Fold 1 (orange) sits lowest the whole time.</a:t>
+            </a:r>
+          </a:p>
+          <a:p>
+            <a:r>
+              <a:t>Middle panel, confusion matrix of the 3-model ensemble on the 2,756 test cells: 1,334 infected cells caught (true positives), 1,355 healthy cells correctly cleared (true negatives), 23 false alarms and 44 infected cells missed. Those 44 misses are why recall is lower, and for diagnosis a miss is the worse mistake.</a:t>
+            </a:r>
+          </a:p>
+          <a:p>
+            <a:r>
+              <a:t>Last panel, ROC curve, zoomed into the top-left corner: the curve hugs the top, ensemble AUC is 99.76 %, the same as the paper. So the model separates the two classes very well; the misses come from where the threshold sits, not from the model being bad at ranking.</a:t>
             </a:r>
           </a:p>
         </p:txBody>
@@ -19334,30 +19424,139 @@
   <p:cSld>
     <p:spTree>
       <p:nvGrpSpPr>
-        <p:cNvPr id="1" name=""/>
+        <p:cNvPr id="2" name=""/>
         <p:cNvGrpSpPr/>
         <p:nvPr/>
       </p:nvGrpSpPr>
       <p:grpSpPr/>
       <p:sp>
         <p:nvSpPr>
-          <p:cNvPr id="2" name="Oval 1"/>
+          <p:cNvPr id="3" name="TextBox 1"/>
+          <p:cNvSpPr txBox="1"/>
+          <p:nvPr/>
+        </p:nvSpPr>
+        <p:spPr>
+          <a:xfrm>
+            <a:off x="548640" y="457200"/>
+            <a:ext cx="11064240" cy="274320"/>
+          </a:xfrm>
+          <a:prstGeom prst="rect">
+            <a:avLst/>
+          </a:prstGeom>
+          <a:noFill/>
+        </p:spPr>
+        <p:txBody>
+          <a:bodyPr wrap="square" lIns="0" rIns="0" tIns="0" bIns="0" anchor="t">
+            <a:spAutoFit/>
+          </a:bodyPr>
+          <a:lstStyle/>
+          <a:p>
+            <a:pPr algn="l"/>
+            <a:r>
+              <a:rPr sz="1250" b="1" i="0">
+                <a:solidFill>
+                  <a:srgbClr val="137C8E"/>
+                </a:solidFill>
+                <a:latin typeface="Calibri"/>
+              </a:rPr>
+              <a:t>MILESTONE 2 · BASELINE REPRODUCTION</a:t>
+            </a:r>
+          </a:p>
+        </p:txBody>
+      </p:sp>
+      <p:sp>
+        <p:nvSpPr>
+          <p:cNvPr id="4" name="TextBox 2"/>
+          <p:cNvSpPr txBox="1"/>
+          <p:nvPr/>
+        </p:nvSpPr>
+        <p:spPr>
+          <a:xfrm>
+            <a:off x="548640" y="749808"/>
+            <a:ext cx="11064240" cy="658368"/>
+          </a:xfrm>
+          <a:prstGeom prst="rect">
+            <a:avLst/>
+          </a:prstGeom>
+          <a:noFill/>
+        </p:spPr>
+        <p:txBody>
+          <a:bodyPr wrap="square" lIns="0" rIns="0" tIns="0" bIns="0" anchor="t">
+            <a:spAutoFit/>
+          </a:bodyPr>
+          <a:lstStyle/>
+          <a:p>
+            <a:pPr algn="l"/>
+            <a:r>
+              <a:rPr sz="3000" b="1" i="0">
+                <a:solidFill>
+                  <a:srgbClr val="17262E"/>
+                </a:solidFill>
+                <a:latin typeface="Cambria"/>
+              </a:rPr>
+              <a:t>A0 results at a glance</a:t>
+            </a:r>
+          </a:p>
+        </p:txBody>
+      </p:sp>
+      <p:sp>
+        <p:nvSpPr>
+          <p:cNvPr id="5" name="TextBox 3"/>
+          <p:cNvSpPr txBox="1"/>
+          <p:nvPr/>
+        </p:nvSpPr>
+        <p:spPr>
+          <a:xfrm>
+            <a:off x="548640" y="1463040"/>
+            <a:ext cx="11064240" cy="457200"/>
+          </a:xfrm>
+          <a:prstGeom prst="rect">
+            <a:avLst/>
+          </a:prstGeom>
+          <a:noFill/>
+        </p:spPr>
+        <p:txBody>
+          <a:bodyPr wrap="square" lIns="0" rIns="0" tIns="0" bIns="0" anchor="t">
+            <a:spAutoFit/>
+          </a:bodyPr>
+          <a:lstStyle/>
+          <a:p>
+            <a:pPr algn="l"/>
+            <a:r>
+              <a:rPr sz="1550" b="0" i="0">
+                <a:solidFill>
+                  <a:srgbClr val="41525B"/>
+                </a:solidFill>
+                <a:latin typeface="Calibri"/>
+              </a:rPr>
+              <a:t>Ensemble of our 3 fold models on the 2,756-image hold-out test set, next to what Marques et al. [8] report.</a:t>
+            </a:r>
+          </a:p>
+        </p:txBody>
+      </p:sp>
+      <p:sp>
+        <p:nvSpPr>
+          <p:cNvPr id="6" name="Rounded Rectangle 6"/>
           <p:cNvSpPr/>
           <p:nvPr/>
         </p:nvSpPr>
         <p:spPr>
           <a:xfrm>
-            <a:off x="11109960" y="320040"/>
-            <a:ext cx="1005840" cy="1005840"/>
-          </a:xfrm>
-          <a:prstGeom prst="ellipse">
-            <a:avLst/>
+            <a:off x="548640" y="2057400"/>
+            <a:ext cx="4454730" cy="2312244"/>
+          </a:xfrm>
+          <a:prstGeom prst="roundRect">
+            <a:avLst>
+              <a:gd name="adj" fmla="val 6000"/>
+            </a:avLst>
           </a:prstGeom>
           <a:solidFill>
-            <a:srgbClr val="8A43B0"/>
+            <a:srgbClr val="EAF3F5"/>
           </a:solidFill>
-          <a:ln>
-            <a:noFill/>
+          <a:ln w="12700">
+            <a:solidFill>
+              <a:srgbClr val="D3E1E6"/>
+            </a:solidFill>
           </a:ln>
           <a:effectLst/>
         </p:spPr>
@@ -19383,23 +19582,86 @@
       </p:sp>
       <p:sp>
         <p:nvSpPr>
-          <p:cNvPr id="3" name="Oval 2"/>
+          <p:cNvPr id="7" name="TextBox 7"/>
+          <p:cNvSpPr txBox="1"/>
+          <p:nvPr/>
+        </p:nvSpPr>
+        <p:spPr>
+          <a:xfrm>
+            <a:off x="685800" y="2194560"/>
+            <a:ext cx="4180410" cy="274320"/>
+          </a:xfrm>
+          <a:prstGeom prst="rect">
+            <a:avLst/>
+          </a:prstGeom>
+          <a:noFill/>
+        </p:spPr>
+        <p:txBody>
+          <a:bodyPr wrap="square" lIns="0" rIns="0" tIns="0" bIns="0" anchor="t">
+            <a:spAutoFit/>
+          </a:bodyPr>
+          <a:lstStyle/>
+          <a:p>
+            <a:pPr algn="l"/>
+            <a:r>
+              <a:rPr sz="1100" b="1" i="0">
+                <a:solidFill>
+                  <a:srgbClr val="137C8E"/>
+                </a:solidFill>
+                <a:latin typeface="Calibri"/>
+              </a:rPr>
+              <a:t>PAPER VS. OURS</a:t>
+            </a:r>
+          </a:p>
+        </p:txBody>
+      </p:sp>
+      <p:pic>
+        <p:nvPicPr>
+          <p:cNvPr id="8" name="Figure Paper" descr="A0_vs_paper.png"/>
+          <p:cNvPicPr>
+            <a:picLocks noChangeAspect="1"/>
+          </p:cNvPicPr>
+          <p:nvPr/>
+        </p:nvPicPr>
+        <p:blipFill>
+          <a:blip r:embed="rId2"/>
+          <a:stretch>
+            <a:fillRect/>
+          </a:stretch>
+        </p:blipFill>
+        <p:spPr>
+          <a:xfrm>
+            <a:off x="685800" y="2560320"/>
+            <a:ext cx="4180410" cy="1672164"/>
+          </a:xfrm>
+          <a:prstGeom prst="rect">
+            <a:avLst/>
+          </a:prstGeom>
+        </p:spPr>
+      </p:pic>
+      <p:sp>
+        <p:nvSpPr>
+          <p:cNvPr id="9" name="Rounded Rectangle 6"/>
           <p:cNvSpPr/>
           <p:nvPr/>
         </p:nvSpPr>
         <p:spPr>
           <a:xfrm>
-            <a:off x="11475720" y="6172200"/>
-            <a:ext cx="822960" cy="822960"/>
-          </a:xfrm>
-          <a:prstGeom prst="ellipse">
-            <a:avLst/>
+            <a:off x="5186250" y="2057400"/>
+            <a:ext cx="6454056" cy="2312244"/>
+          </a:xfrm>
+          <a:prstGeom prst="roundRect">
+            <a:avLst>
+              <a:gd name="adj" fmla="val 6000"/>
+            </a:avLst>
           </a:prstGeom>
           <a:solidFill>
-            <a:srgbClr val="137C8E"/>
+            <a:srgbClr val="EAF3F5"/>
           </a:solidFill>
-          <a:ln>
-            <a:noFill/>
+          <a:ln w="12700">
+            <a:solidFill>
+              <a:srgbClr val="D3E1E6"/>
+            </a:solidFill>
           </a:ln>
           <a:effectLst/>
         </p:spPr>
@@ -19425,22 +19687,300 @@
       </p:sp>
       <p:sp>
         <p:nvSpPr>
-          <p:cNvPr id="4" name="Rounded Rectangle 3"/>
+          <p:cNvPr id="10" name="TextBox 7"/>
+          <p:cNvSpPr txBox="1"/>
+          <p:nvPr/>
+        </p:nvSpPr>
+        <p:spPr>
+          <a:xfrm>
+            <a:off x="5323410" y="2194560"/>
+            <a:ext cx="6179736" cy="274320"/>
+          </a:xfrm>
+          <a:prstGeom prst="rect">
+            <a:avLst/>
+          </a:prstGeom>
+          <a:noFill/>
+        </p:spPr>
+        <p:txBody>
+          <a:bodyPr wrap="square" lIns="0" rIns="0" tIns="0" bIns="0" anchor="t">
+            <a:spAutoFit/>
+          </a:bodyPr>
+          <a:lstStyle/>
+          <a:p>
+            <a:pPr algn="l"/>
+            <a:r>
+              <a:rPr sz="1100" b="1" i="0">
+                <a:solidFill>
+                  <a:srgbClr val="137C8E"/>
+                </a:solidFill>
+                <a:latin typeface="Calibri"/>
+              </a:rPr>
+              <a:t>TRAINING CURVES · CONFUSION MATRIX · ROC</a:t>
+            </a:r>
+          </a:p>
+        </p:txBody>
+      </p:sp>
+      <p:pic>
+        <p:nvPicPr>
+          <p:cNvPr id="11" name="Figure Training" descr="A0_curves_cm_roc.png"/>
+          <p:cNvPicPr>
+            <a:picLocks noChangeAspect="1"/>
+          </p:cNvPicPr>
+          <p:nvPr/>
+        </p:nvPicPr>
+        <p:blipFill>
+          <a:blip r:embed="rId3"/>
+          <a:stretch>
+            <a:fillRect/>
+          </a:stretch>
+        </p:blipFill>
+        <p:spPr>
+          <a:xfrm>
+            <a:off x="5323410" y="2560320"/>
+            <a:ext cx="6179736" cy="1672164"/>
+          </a:xfrm>
+          <a:prstGeom prst="rect">
+            <a:avLst/>
+          </a:prstGeom>
+        </p:spPr>
+      </p:pic>
+      <p:sp>
+        <p:nvSpPr>
+          <p:cNvPr id="12" name="Shape 15"/>
           <p:cNvSpPr/>
           <p:nvPr/>
         </p:nvSpPr>
         <p:spPr>
           <a:xfrm>
-            <a:off x="640080" y="502920"/>
-            <a:ext cx="2377440" cy="402336"/>
+            <a:off x="548640" y="4689684"/>
+            <a:ext cx="11091672" cy="868680"/>
           </a:xfrm>
           <a:prstGeom prst="roundRect">
             <a:avLst>
-              <a:gd name="adj" fmla="val 50000"/>
+              <a:gd name="adj" fmla="val 10526"/>
             </a:avLst>
           </a:prstGeom>
           <a:solidFill>
-            <a:srgbClr val="D99A00"/>
+            <a:srgbClr val="0F2E3D"/>
+          </a:solidFill>
+          <a:ln/>
+        </p:spPr>
+        <p:txBody>
+          <a:bodyPr/>
+          <a:p/>
+        </p:txBody>
+      </p:sp>
+      <p:sp>
+        <p:nvSpPr>
+          <p:cNvPr id="13" name="Shape 16"/>
+          <p:cNvSpPr/>
+          <p:nvPr/>
+        </p:nvSpPr>
+        <p:spPr>
+          <a:xfrm>
+            <a:off x="905256" y="4790268"/>
+            <a:ext cx="658368" cy="658368"/>
+          </a:xfrm>
+          <a:prstGeom prst="ellipse">
+            <a:avLst/>
+          </a:prstGeom>
+          <a:solidFill>
+            <a:srgbClr val="2EA79B"/>
+          </a:solidFill>
+          <a:ln/>
+        </p:spPr>
+        <p:txBody>
+          <a:bodyPr/>
+          <a:p/>
+        </p:txBody>
+      </p:sp>
+      <p:pic>
+        <p:nvPicPr>
+          <p:cNvPr id="14" name="Image 3" descr="/tmp/build/assets/ic_bolt.png">    </p:cNvPr>
+          <p:cNvPicPr>
+            <a:picLocks noChangeAspect="1"/>
+          </p:cNvPicPr>
+          <p:nvPr/>
+        </p:nvPicPr>
+        <p:blipFill>
+          <a:blip r:embed="rId4"/>
+          <a:stretch>
+            <a:fillRect/>
+          </a:stretch>
+        </p:blipFill>
+        <p:spPr>
+          <a:xfrm>
+            <a:off x="1069848" y="4954860"/>
+            <a:ext cx="329184" cy="329184"/>
+          </a:xfrm>
+          <a:prstGeom prst="rect">
+            <a:avLst/>
+          </a:prstGeom>
+        </p:spPr>
+      </p:pic>
+      <p:sp>
+        <p:nvSpPr>
+          <p:cNvPr id="15" name="Text 17"/>
+          <p:cNvSpPr txBox="1"/>
+          <p:nvPr/>
+        </p:nvSpPr>
+        <p:spPr>
+          <a:xfrm>
+            <a:off x="1783080" y="4689684"/>
+            <a:ext cx="9601200" cy="868680"/>
+          </a:xfrm>
+          <a:prstGeom prst="rect">
+            <a:avLst/>
+          </a:prstGeom>
+          <a:noFill/>
+          <a:ln/>
+        </p:spPr>
+        <p:txBody>
+          <a:bodyPr wrap="square" lIns="0" tIns="0" rIns="0" bIns="0" rtlCol="0" anchor="ctr"/>
+          <a:lstStyle/>
+          <a:p>
+            <a:pPr indent="0" marL="0">
+              <a:lnSpc>
+                <a:spcPct val="105000"/>
+              </a:lnSpc>
+              <a:buNone/>
+            </a:pPr>
+            <a:r>
+              <a:rPr lang="en-US" sz="1550" b="1" dirty="0">
+                <a:solidFill>
+                  <a:srgbClr val="2EA79B"/>
+                </a:solidFill>
+                <a:latin typeface="Calibri" pitchFamily="34" charset="0"/>
+                <a:ea typeface="Calibri" pitchFamily="34" charset="-122"/>
+                <a:cs typeface="Calibri" pitchFamily="34" charset="-120"/>
+              </a:rPr>
+              <a:t>Takeaway:  </a:t>
+            </a:r>
+            <a:pPr indent="0" marL="0">
+              <a:lnSpc>
+                <a:spcPct val="105000"/>
+              </a:lnSpc>
+              <a:buNone/>
+            </a:pPr>
+            <a:r>
+              <a:rPr lang="en-US" sz="1550" dirty="0">
+                <a:solidFill>
+                  <a:srgbClr val="E8F2F4"/>
+                </a:solidFill>
+                <a:latin typeface="Calibri" pitchFamily="34" charset="0"/>
+                <a:ea typeface="Calibri" pitchFamily="34" charset="-122"/>
+                <a:cs typeface="Calibri" pitchFamily="34" charset="-120"/>
+              </a:rPr>
+              <a:t>Within 1 pp of the paper on both headline accuracies; recall is 2 pp lower (44 missed infected cells).</a:t>
+            </a:r>
+            <a:endParaRPr lang="en-US" sz="1550" dirty="0"/>
+          </a:p>
+        </p:txBody>
+      </p:sp>
+      <p:sp>
+        <p:nvSpPr>
+          <p:cNvPr id="16" name="TextBox 10"/>
+          <p:cNvSpPr txBox="1"/>
+          <p:nvPr/>
+        </p:nvSpPr>
+        <p:spPr>
+          <a:xfrm>
+            <a:off x="548640" y="6455664"/>
+            <a:ext cx="7315200" cy="274320"/>
+          </a:xfrm>
+          <a:prstGeom prst="rect">
+            <a:avLst/>
+          </a:prstGeom>
+          <a:noFill/>
+        </p:spPr>
+        <p:txBody>
+          <a:bodyPr wrap="square" lIns="0" rIns="0" tIns="0" bIns="0" anchor="t">
+            <a:spAutoFit/>
+          </a:bodyPr>
+          <a:lstStyle/>
+          <a:p>
+            <a:pPr algn="l"/>
+            <a:r>
+              <a:rPr sz="900" b="0" i="0">
+                <a:solidFill>
+                  <a:srgbClr val="7C8B93"/>
+                </a:solidFill>
+                <a:latin typeface="Calibri"/>
+              </a:rPr>
+              <a:t>Phase 2 · Baseline &amp; Hypothesis · Automated Malaria Cell Detection</a:t>
+            </a:r>
+          </a:p>
+        </p:txBody>
+      </p:sp>
+      <p:sp>
+        <p:nvSpPr>
+          <p:cNvPr id="17" name="TextBox 11"/>
+          <p:cNvSpPr txBox="1"/>
+          <p:nvPr/>
+        </p:nvSpPr>
+        <p:spPr>
+          <a:xfrm>
+            <a:off x="11183112" y="6419088"/>
+            <a:ext cx="457200" cy="274320"/>
+          </a:xfrm>
+          <a:prstGeom prst="rect">
+            <a:avLst/>
+          </a:prstGeom>
+          <a:noFill/>
+        </p:spPr>
+        <p:txBody>
+          <a:bodyPr wrap="square" lIns="0" rIns="0" tIns="0" bIns="0" anchor="t">
+            <a:spAutoFit/>
+          </a:bodyPr>
+          <a:lstStyle/>
+          <a:p>
+            <a:pPr algn="r"/>
+            <a:r>
+              <a:rPr sz="1000" b="0" i="0">
+                <a:solidFill>
+                  <a:srgbClr val="7C8B93"/>
+                </a:solidFill>
+                <a:latin typeface="Calibri"/>
+              </a:rPr>
+              <a:t>20</a:t>
+            </a:r>
+          </a:p>
+        </p:txBody>
+      </p:sp>
+    </p:spTree>
+  </p:cSld>
+  <p:clrMapOvr>
+    <a:masterClrMapping/>
+  </p:clrMapOvr>
+</p:sld>
+</file>
+
+<file path=ppt/slides/slide21.xml><?xml version="1.0" encoding="utf-8"?>
+<p:sld xmlns:a="http://schemas.openxmlformats.org/drawingml/2006/main" xmlns:p="http://schemas.openxmlformats.org/presentationml/2006/main" xmlns:r="http://schemas.openxmlformats.org/officeDocument/2006/relationships">
+  <p:cSld>
+    <p:spTree>
+      <p:nvGrpSpPr>
+        <p:cNvPr id="1" name=""/>
+        <p:cNvGrpSpPr/>
+        <p:nvPr/>
+      </p:nvGrpSpPr>
+      <p:grpSpPr/>
+      <p:sp>
+        <p:nvSpPr>
+          <p:cNvPr id="2" name="Oval 1"/>
+          <p:cNvSpPr/>
+          <p:nvPr/>
+        </p:nvSpPr>
+        <p:spPr>
+          <a:xfrm>
+            <a:off x="11109960" y="320040"/>
+            <a:ext cx="1005840" cy="1005840"/>
+          </a:xfrm>
+          <a:prstGeom prst="ellipse">
+            <a:avLst/>
+          </a:prstGeom>
+          <a:solidFill>
+            <a:srgbClr val="8A43B0"/>
           </a:solidFill>
           <a:ln>
             <a:noFill/>
@@ -19469,97 +20009,23 @@
       </p:sp>
       <p:sp>
         <p:nvSpPr>
-          <p:cNvPr id="5" name="TextBox 4"/>
-          <p:cNvSpPr txBox="1"/>
-          <p:nvPr/>
-        </p:nvSpPr>
-        <p:spPr>
-          <a:xfrm>
-            <a:off x="640080" y="502920"/>
-            <a:ext cx="2377440" cy="402336"/>
-          </a:xfrm>
-          <a:prstGeom prst="rect">
-            <a:avLst/>
-          </a:prstGeom>
-          <a:noFill/>
-        </p:spPr>
-        <p:txBody>
-          <a:bodyPr wrap="square" lIns="0" rIns="0" tIns="0" bIns="0" anchor="ctr">
-            <a:spAutoFit/>
-          </a:bodyPr>
-          <a:lstStyle/>
-          <a:p>
-            <a:pPr algn="ctr"/>
-            <a:r>
-              <a:rPr sz="1250" b="1" i="0">
-                <a:solidFill>
-                  <a:srgbClr val="3A2A00"/>
-                </a:solidFill>
-                <a:latin typeface="Calibri"/>
-              </a:rPr>
-              <a:t>★ OUR HYPOTHESIS</a:t>
-            </a:r>
-          </a:p>
-        </p:txBody>
-      </p:sp>
-      <p:sp>
-        <p:nvSpPr>
-          <p:cNvPr id="6" name="TextBox 5"/>
-          <p:cNvSpPr txBox="1"/>
-          <p:nvPr/>
-        </p:nvSpPr>
-        <p:spPr>
-          <a:xfrm>
-            <a:off x="640080" y="1024128"/>
-            <a:ext cx="10972800" cy="640080"/>
-          </a:xfrm>
-          <a:prstGeom prst="rect">
-            <a:avLst/>
-          </a:prstGeom>
-          <a:noFill/>
-        </p:spPr>
-        <p:txBody>
-          <a:bodyPr wrap="square" lIns="0" rIns="0" tIns="0" bIns="0" anchor="t">
-            <a:spAutoFit/>
-          </a:bodyPr>
-          <a:lstStyle/>
-          <a:p>
-            <a:pPr algn="l"/>
-            <a:r>
-              <a:rPr sz="3000" b="1" i="0">
-                <a:solidFill>
-                  <a:srgbClr val="FFFFFF"/>
-                </a:solidFill>
-                <a:latin typeface="Cambria"/>
-              </a:rPr>
-              <a:t>Two proposed changes, one variable at a time</a:t>
-            </a:r>
-          </a:p>
-        </p:txBody>
-      </p:sp>
-      <p:sp>
-        <p:nvSpPr>
-          <p:cNvPr id="7" name="Rounded Rectangle 6"/>
+          <p:cNvPr id="3" name="Oval 2"/>
           <p:cNvSpPr/>
           <p:nvPr/>
         </p:nvSpPr>
         <p:spPr>
           <a:xfrm>
-            <a:off x="640080" y="1828800"/>
-            <a:ext cx="5468112" cy="3931920"/>
-          </a:xfrm>
-          <a:prstGeom prst="roundRect">
-            <a:avLst>
-              <a:gd name="adj" fmla="val 6000"/>
-            </a:avLst>
+            <a:off x="11475720" y="6172200"/>
+            <a:ext cx="822960" cy="822960"/>
+          </a:xfrm>
+          <a:prstGeom prst="ellipse">
+            <a:avLst/>
           </a:prstGeom>
           <a:solidFill>
-            <a:srgbClr val="15455A"/>
+            <a:srgbClr val="137C8E"/>
           </a:solidFill>
-          <a:ln w="12700">
-            <a:solidFill>
-              <a:srgbClr val="0E6274"/>
-            </a:solidFill>
+          <a:ln>
+            <a:noFill/>
           </a:ln>
           <a:effectLst/>
         </p:spPr>
@@ -19585,20 +20051,22 @@
       </p:sp>
       <p:sp>
         <p:nvSpPr>
-          <p:cNvPr id="8" name="Oval 7"/>
+          <p:cNvPr id="4" name="Rounded Rectangle 3"/>
           <p:cNvSpPr/>
           <p:nvPr/>
         </p:nvSpPr>
         <p:spPr>
           <a:xfrm>
-            <a:off x="914400" y="2057400"/>
-            <a:ext cx="731520" cy="731520"/>
-          </a:xfrm>
-          <a:prstGeom prst="ellipse">
-            <a:avLst/>
+            <a:off x="640080" y="502920"/>
+            <a:ext cx="2377440" cy="402336"/>
+          </a:xfrm>
+          <a:prstGeom prst="roundRect">
+            <a:avLst>
+              <a:gd name="adj" fmla="val 50000"/>
+            </a:avLst>
           </a:prstGeom>
           <a:solidFill>
-            <a:srgbClr val="CC4A3F"/>
+            <a:srgbClr val="D99A00"/>
           </a:solidFill>
           <a:ln>
             <a:noFill/>
@@ -19625,40 +20093,51 @@
           <a:p/>
         </p:txBody>
       </p:sp>
-      <p:pic>
-        <p:nvPicPr>
-          <p:cNvPr id="9" name="Picture 8" descr="image.png"/>
-          <p:cNvPicPr>
-            <a:picLocks noChangeAspect="1"/>
-          </p:cNvPicPr>
-          <p:nvPr/>
-        </p:nvPicPr>
-        <p:blipFill>
-          <a:blip r:embed="rId2"/>
-          <a:stretch>
-            <a:fillRect/>
-          </a:stretch>
-        </p:blipFill>
-        <p:spPr>
-          <a:xfrm>
-            <a:off x="1097280" y="2240280"/>
-            <a:ext cx="365760" cy="365760"/>
-          </a:xfrm>
-          <a:prstGeom prst="rect">
-            <a:avLst/>
-          </a:prstGeom>
-        </p:spPr>
-      </p:pic>
-      <p:sp>
-        <p:nvSpPr>
-          <p:cNvPr id="10" name="TextBox 9"/>
-          <p:cNvSpPr txBox="1"/>
-          <p:nvPr/>
-        </p:nvSpPr>
-        <p:spPr>
-          <a:xfrm>
-            <a:off x="1828800" y="2048256"/>
-            <a:ext cx="4069080" cy="274320"/>
+      <p:sp>
+        <p:nvSpPr>
+          <p:cNvPr id="5" name="TextBox 4"/>
+          <p:cNvSpPr txBox="1"/>
+          <p:nvPr/>
+        </p:nvSpPr>
+        <p:spPr>
+          <a:xfrm>
+            <a:off x="640080" y="502920"/>
+            <a:ext cx="2377440" cy="402336"/>
+          </a:xfrm>
+          <a:prstGeom prst="rect">
+            <a:avLst/>
+          </a:prstGeom>
+          <a:noFill/>
+        </p:spPr>
+        <p:txBody>
+          <a:bodyPr wrap="square" lIns="0" rIns="0" tIns="0" bIns="0" anchor="ctr">
+            <a:spAutoFit/>
+          </a:bodyPr>
+          <a:lstStyle/>
+          <a:p>
+            <a:pPr algn="ctr"/>
+            <a:r>
+              <a:rPr sz="1250" b="1" i="0">
+                <a:solidFill>
+                  <a:srgbClr val="3A2A00"/>
+                </a:solidFill>
+                <a:latin typeface="Calibri"/>
+              </a:rPr>
+              <a:t>★ OUR HYPOTHESIS</a:t>
+            </a:r>
+          </a:p>
+        </p:txBody>
+      </p:sp>
+      <p:sp>
+        <p:nvSpPr>
+          <p:cNvPr id="6" name="TextBox 5"/>
+          <p:cNvSpPr txBox="1"/>
+          <p:nvPr/>
+        </p:nvSpPr>
+        <p:spPr>
+          <a:xfrm>
+            <a:off x="640080" y="1024128"/>
+            <a:ext cx="10972800" cy="640080"/>
           </a:xfrm>
           <a:prstGeom prst="rect">
             <a:avLst/>
@@ -19673,271 +20152,26 @@
           <a:p>
             <a:pPr algn="l"/>
             <a:r>
-              <a:rPr sz="1100" b="1" i="0">
-                <a:solidFill>
-                  <a:srgbClr val="9FC0C9"/>
-                </a:solidFill>
-                <a:latin typeface="Calibri"/>
-              </a:rPr>
-              <a:t>H1 · VALIDATION</a:t>
-            </a:r>
-          </a:p>
-        </p:txBody>
-      </p:sp>
-      <p:sp>
-        <p:nvSpPr>
-          <p:cNvPr id="11" name="TextBox 10"/>
-          <p:cNvSpPr txBox="1"/>
-          <p:nvPr/>
-        </p:nvSpPr>
-        <p:spPr>
-          <a:xfrm>
-            <a:off x="1828800" y="2304288"/>
-            <a:ext cx="4114800" cy="502920"/>
-          </a:xfrm>
-          <a:prstGeom prst="rect">
-            <a:avLst/>
-          </a:prstGeom>
-          <a:noFill/>
-        </p:spPr>
-        <p:txBody>
-          <a:bodyPr wrap="square" lIns="0" rIns="0" tIns="0" bIns="0" anchor="t">
-            <a:spAutoFit/>
-          </a:bodyPr>
-          <a:lstStyle/>
-          <a:p>
-            <a:pPr algn="l"/>
-            <a:r>
-              <a:rPr sz="1650" b="1" i="0">
+              <a:rPr sz="3000" b="1" i="0">
                 <a:solidFill>
                   <a:srgbClr val="FFFFFF"/>
                 </a:solidFill>
                 <a:latin typeface="Cambria"/>
               </a:rPr>
-              <a:t>Leakage-free, slide-grouped split</a:t>
-            </a:r>
-          </a:p>
-        </p:txBody>
-      </p:sp>
-      <p:sp>
-        <p:nvSpPr>
-          <p:cNvPr id="12" name="TextBox 11"/>
-          <p:cNvSpPr txBox="1"/>
-          <p:nvPr/>
-        </p:nvSpPr>
-        <p:spPr>
-          <a:xfrm>
-            <a:off x="932688" y="3017520"/>
-            <a:ext cx="1188720" cy="274320"/>
-          </a:xfrm>
-          <a:prstGeom prst="rect">
-            <a:avLst/>
-          </a:prstGeom>
-          <a:noFill/>
-        </p:spPr>
-        <p:txBody>
-          <a:bodyPr wrap="square" lIns="0" rIns="0" tIns="0" bIns="0" anchor="t">
-            <a:spAutoFit/>
-          </a:bodyPr>
-          <a:lstStyle/>
-          <a:p>
-            <a:pPr algn="l"/>
-            <a:r>
-              <a:rPr sz="1050" b="1" i="0">
-                <a:solidFill>
-                  <a:srgbClr val="9FC0C9"/>
-                </a:solidFill>
-                <a:latin typeface="Calibri"/>
-              </a:rPr>
-              <a:t>CHANGE</a:t>
-            </a:r>
-          </a:p>
-        </p:txBody>
-      </p:sp>
-      <p:sp>
-        <p:nvSpPr>
-          <p:cNvPr id="13" name="TextBox 12"/>
-          <p:cNvSpPr txBox="1"/>
-          <p:nvPr/>
-        </p:nvSpPr>
-        <p:spPr>
-          <a:xfrm>
-            <a:off x="2057400" y="2990088"/>
-            <a:ext cx="3840480" cy="868680"/>
-          </a:xfrm>
-          <a:prstGeom prst="rect">
-            <a:avLst/>
-          </a:prstGeom>
-          <a:noFill/>
-        </p:spPr>
-        <p:txBody>
-          <a:bodyPr wrap="square" lIns="0" rIns="0" tIns="0" bIns="0" anchor="t">
-            <a:spAutoFit/>
-          </a:bodyPr>
-          <a:lstStyle/>
-          <a:p>
-            <a:pPr algn="l"/>
-            <a:r>
-              <a:rPr sz="1200" b="0" i="0">
-                <a:solidFill>
-                  <a:srgbClr val="D5E6EA"/>
-                </a:solidFill>
-                <a:latin typeface="Calibri"/>
-              </a:rPr>
-              <a:t>Split by slide/patient (StratifiedGroupKFold) instead of random images. Model unchanged.</a:t>
-            </a:r>
-          </a:p>
-        </p:txBody>
-      </p:sp>
-      <p:sp>
-        <p:nvSpPr>
-          <p:cNvPr id="14" name="TextBox 13"/>
-          <p:cNvSpPr txBox="1"/>
-          <p:nvPr/>
-        </p:nvSpPr>
-        <p:spPr>
-          <a:xfrm>
-            <a:off x="932688" y="3913631"/>
-            <a:ext cx="1188720" cy="274320"/>
-          </a:xfrm>
-          <a:prstGeom prst="rect">
-            <a:avLst/>
-          </a:prstGeom>
-          <a:noFill/>
-        </p:spPr>
-        <p:txBody>
-          <a:bodyPr wrap="square" lIns="0" rIns="0" tIns="0" bIns="0" anchor="t">
-            <a:spAutoFit/>
-          </a:bodyPr>
-          <a:lstStyle/>
-          <a:p>
-            <a:pPr algn="l"/>
-            <a:r>
-              <a:rPr sz="1050" b="1" i="0">
-                <a:solidFill>
-                  <a:srgbClr val="D99A00"/>
-                </a:solidFill>
-                <a:latin typeface="Calibri"/>
-              </a:rPr>
-              <a:t>WE EXPECT</a:t>
-            </a:r>
-          </a:p>
-        </p:txBody>
-      </p:sp>
-      <p:sp>
-        <p:nvSpPr>
-          <p:cNvPr id="15" name="TextBox 14"/>
-          <p:cNvSpPr txBox="1"/>
-          <p:nvPr/>
-        </p:nvSpPr>
-        <p:spPr>
-          <a:xfrm>
-            <a:off x="2057400" y="3886199"/>
-            <a:ext cx="3840480" cy="868680"/>
-          </a:xfrm>
-          <a:prstGeom prst="rect">
-            <a:avLst/>
-          </a:prstGeom>
-          <a:noFill/>
-        </p:spPr>
-        <p:txBody>
-          <a:bodyPr wrap="square" lIns="0" rIns="0" tIns="0" bIns="0" anchor="t">
-            <a:spAutoFit/>
-          </a:bodyPr>
-          <a:lstStyle/>
-          <a:p>
-            <a:pPr algn="l"/>
-            <a:r>
-              <a:rPr sz="1200" b="1" i="0">
-                <a:solidFill>
-                  <a:srgbClr val="FFFFFF"/>
-                </a:solidFill>
-                <a:latin typeface="Calibri"/>
-              </a:rPr>
-              <a:t>Accuracy and MCC fall below the image-split baseline, and fold-to-fold spread widens.</a:t>
-            </a:r>
-          </a:p>
-        </p:txBody>
-      </p:sp>
-      <p:sp>
-        <p:nvSpPr>
-          <p:cNvPr id="16" name="TextBox 15"/>
-          <p:cNvSpPr txBox="1"/>
-          <p:nvPr/>
-        </p:nvSpPr>
-        <p:spPr>
-          <a:xfrm>
-            <a:off x="932688" y="4809744"/>
-            <a:ext cx="1188720" cy="274320"/>
-          </a:xfrm>
-          <a:prstGeom prst="rect">
-            <a:avLst/>
-          </a:prstGeom>
-          <a:noFill/>
-        </p:spPr>
-        <p:txBody>
-          <a:bodyPr wrap="square" lIns="0" rIns="0" tIns="0" bIns="0" anchor="t">
-            <a:spAutoFit/>
-          </a:bodyPr>
-          <a:lstStyle/>
-          <a:p>
-            <a:pPr algn="l"/>
-            <a:r>
-              <a:rPr sz="1050" b="1" i="0">
-                <a:solidFill>
-                  <a:srgbClr val="9FC0C9"/>
-                </a:solidFill>
-                <a:latin typeface="Calibri"/>
-              </a:rPr>
-              <a:t>BECAUSE</a:t>
-            </a:r>
-          </a:p>
-        </p:txBody>
-      </p:sp>
-      <p:sp>
-        <p:nvSpPr>
-          <p:cNvPr id="17" name="TextBox 16"/>
-          <p:cNvSpPr txBox="1"/>
-          <p:nvPr/>
-        </p:nvSpPr>
-        <p:spPr>
-          <a:xfrm>
-            <a:off x="2057400" y="4782312"/>
-            <a:ext cx="3840480" cy="868680"/>
-          </a:xfrm>
-          <a:prstGeom prst="rect">
-            <a:avLst/>
-          </a:prstGeom>
-          <a:noFill/>
-        </p:spPr>
-        <p:txBody>
-          <a:bodyPr wrap="square" lIns="0" rIns="0" tIns="0" bIns="0" anchor="t">
-            <a:spAutoFit/>
-          </a:bodyPr>
-          <a:lstStyle/>
-          <a:p>
-            <a:pPr algn="l"/>
-            <a:r>
-              <a:rPr sz="1200" b="0" i="0">
-                <a:solidFill>
-                  <a:srgbClr val="D5E6EA"/>
-                </a:solidFill>
-                <a:latin typeface="Calibri"/>
-              </a:rPr>
-              <a:t>Cells from one slide share stain, lighting and the patient's cell shape. A random split lets the model recognise the slide rather than the parasite.</a:t>
-            </a:r>
-          </a:p>
-        </p:txBody>
-      </p:sp>
-      <p:sp>
-        <p:nvSpPr>
-          <p:cNvPr id="18" name="Rounded Rectangle 17"/>
+              <a:t>Two proposed changes, one variable at a time</a:t>
+            </a:r>
+          </a:p>
+        </p:txBody>
+      </p:sp>
+      <p:sp>
+        <p:nvSpPr>
+          <p:cNvPr id="7" name="Rounded Rectangle 6"/>
           <p:cNvSpPr/>
           <p:nvPr/>
         </p:nvSpPr>
         <p:spPr>
           <a:xfrm>
-            <a:off x="6345936" y="1828800"/>
+            <a:off x="640080" y="1828800"/>
             <a:ext cx="5468112" cy="3931920"/>
           </a:xfrm>
           <a:prstGeom prst="roundRect">
@@ -19977,20 +20211,20 @@
       </p:sp>
       <p:sp>
         <p:nvSpPr>
-          <p:cNvPr id="19" name="Oval 18"/>
+          <p:cNvPr id="8" name="Oval 7"/>
           <p:cNvSpPr/>
           <p:nvPr/>
         </p:nvSpPr>
         <p:spPr>
           <a:xfrm>
-            <a:off x="6620256" y="2057400"/>
+            <a:off x="914400" y="2057400"/>
             <a:ext cx="731520" cy="731520"/>
           </a:xfrm>
           <a:prstGeom prst="ellipse">
             <a:avLst/>
           </a:prstGeom>
           <a:solidFill>
-            <a:srgbClr val="2EA79B"/>
+            <a:srgbClr val="CC4A3F"/>
           </a:solidFill>
           <a:ln>
             <a:noFill/>
@@ -20019,6 +20253,398 @@
       </p:sp>
       <p:pic>
         <p:nvPicPr>
+          <p:cNvPr id="9" name="Picture 8" descr="image.png"/>
+          <p:cNvPicPr>
+            <a:picLocks noChangeAspect="1"/>
+          </p:cNvPicPr>
+          <p:nvPr/>
+        </p:nvPicPr>
+        <p:blipFill>
+          <a:blip r:embed="rId2"/>
+          <a:stretch>
+            <a:fillRect/>
+          </a:stretch>
+        </p:blipFill>
+        <p:spPr>
+          <a:xfrm>
+            <a:off x="1097280" y="2240280"/>
+            <a:ext cx="365760" cy="365760"/>
+          </a:xfrm>
+          <a:prstGeom prst="rect">
+            <a:avLst/>
+          </a:prstGeom>
+        </p:spPr>
+      </p:pic>
+      <p:sp>
+        <p:nvSpPr>
+          <p:cNvPr id="10" name="TextBox 9"/>
+          <p:cNvSpPr txBox="1"/>
+          <p:nvPr/>
+        </p:nvSpPr>
+        <p:spPr>
+          <a:xfrm>
+            <a:off x="1828800" y="2048256"/>
+            <a:ext cx="4069080" cy="274320"/>
+          </a:xfrm>
+          <a:prstGeom prst="rect">
+            <a:avLst/>
+          </a:prstGeom>
+          <a:noFill/>
+        </p:spPr>
+        <p:txBody>
+          <a:bodyPr wrap="square" lIns="0" rIns="0" tIns="0" bIns="0" anchor="t">
+            <a:spAutoFit/>
+          </a:bodyPr>
+          <a:lstStyle/>
+          <a:p>
+            <a:pPr algn="l"/>
+            <a:r>
+              <a:rPr sz="1100" b="1" i="0">
+                <a:solidFill>
+                  <a:srgbClr val="9FC0C9"/>
+                </a:solidFill>
+                <a:latin typeface="Calibri"/>
+              </a:rPr>
+              <a:t>H1 · VALIDATION</a:t>
+            </a:r>
+          </a:p>
+        </p:txBody>
+      </p:sp>
+      <p:sp>
+        <p:nvSpPr>
+          <p:cNvPr id="11" name="TextBox 10"/>
+          <p:cNvSpPr txBox="1"/>
+          <p:nvPr/>
+        </p:nvSpPr>
+        <p:spPr>
+          <a:xfrm>
+            <a:off x="1828800" y="2304288"/>
+            <a:ext cx="4114800" cy="502920"/>
+          </a:xfrm>
+          <a:prstGeom prst="rect">
+            <a:avLst/>
+          </a:prstGeom>
+          <a:noFill/>
+        </p:spPr>
+        <p:txBody>
+          <a:bodyPr wrap="square" lIns="0" rIns="0" tIns="0" bIns="0" anchor="t">
+            <a:spAutoFit/>
+          </a:bodyPr>
+          <a:lstStyle/>
+          <a:p>
+            <a:pPr algn="l"/>
+            <a:r>
+              <a:rPr sz="1650" b="1" i="0">
+                <a:solidFill>
+                  <a:srgbClr val="FFFFFF"/>
+                </a:solidFill>
+                <a:latin typeface="Cambria"/>
+              </a:rPr>
+              <a:t>Leakage-free, slide-grouped split</a:t>
+            </a:r>
+          </a:p>
+        </p:txBody>
+      </p:sp>
+      <p:sp>
+        <p:nvSpPr>
+          <p:cNvPr id="12" name="TextBox 11"/>
+          <p:cNvSpPr txBox="1"/>
+          <p:nvPr/>
+        </p:nvSpPr>
+        <p:spPr>
+          <a:xfrm>
+            <a:off x="932688" y="3017520"/>
+            <a:ext cx="1188720" cy="274320"/>
+          </a:xfrm>
+          <a:prstGeom prst="rect">
+            <a:avLst/>
+          </a:prstGeom>
+          <a:noFill/>
+        </p:spPr>
+        <p:txBody>
+          <a:bodyPr wrap="square" lIns="0" rIns="0" tIns="0" bIns="0" anchor="t">
+            <a:spAutoFit/>
+          </a:bodyPr>
+          <a:lstStyle/>
+          <a:p>
+            <a:pPr algn="l"/>
+            <a:r>
+              <a:rPr sz="1050" b="1" i="0">
+                <a:solidFill>
+                  <a:srgbClr val="9FC0C9"/>
+                </a:solidFill>
+                <a:latin typeface="Calibri"/>
+              </a:rPr>
+              <a:t>CHANGE</a:t>
+            </a:r>
+          </a:p>
+        </p:txBody>
+      </p:sp>
+      <p:sp>
+        <p:nvSpPr>
+          <p:cNvPr id="13" name="TextBox 12"/>
+          <p:cNvSpPr txBox="1"/>
+          <p:nvPr/>
+        </p:nvSpPr>
+        <p:spPr>
+          <a:xfrm>
+            <a:off x="2057400" y="2990088"/>
+            <a:ext cx="3840480" cy="868680"/>
+          </a:xfrm>
+          <a:prstGeom prst="rect">
+            <a:avLst/>
+          </a:prstGeom>
+          <a:noFill/>
+        </p:spPr>
+        <p:txBody>
+          <a:bodyPr wrap="square" lIns="0" rIns="0" tIns="0" bIns="0" anchor="t">
+            <a:spAutoFit/>
+          </a:bodyPr>
+          <a:lstStyle/>
+          <a:p>
+            <a:pPr algn="l"/>
+            <a:r>
+              <a:rPr sz="1200" b="0" i="0">
+                <a:solidFill>
+                  <a:srgbClr val="D5E6EA"/>
+                </a:solidFill>
+                <a:latin typeface="Calibri"/>
+              </a:rPr>
+              <a:t>Split by slide/patient (StratifiedGroupKFold) instead of random images. Model unchanged.</a:t>
+            </a:r>
+          </a:p>
+        </p:txBody>
+      </p:sp>
+      <p:sp>
+        <p:nvSpPr>
+          <p:cNvPr id="14" name="TextBox 13"/>
+          <p:cNvSpPr txBox="1"/>
+          <p:nvPr/>
+        </p:nvSpPr>
+        <p:spPr>
+          <a:xfrm>
+            <a:off x="932688" y="3913631"/>
+            <a:ext cx="1188720" cy="274320"/>
+          </a:xfrm>
+          <a:prstGeom prst="rect">
+            <a:avLst/>
+          </a:prstGeom>
+          <a:noFill/>
+        </p:spPr>
+        <p:txBody>
+          <a:bodyPr wrap="square" lIns="0" rIns="0" tIns="0" bIns="0" anchor="t">
+            <a:spAutoFit/>
+          </a:bodyPr>
+          <a:lstStyle/>
+          <a:p>
+            <a:pPr algn="l"/>
+            <a:r>
+              <a:rPr sz="1050" b="1" i="0">
+                <a:solidFill>
+                  <a:srgbClr val="D99A00"/>
+                </a:solidFill>
+                <a:latin typeface="Calibri"/>
+              </a:rPr>
+              <a:t>WE EXPECT</a:t>
+            </a:r>
+          </a:p>
+        </p:txBody>
+      </p:sp>
+      <p:sp>
+        <p:nvSpPr>
+          <p:cNvPr id="15" name="TextBox 14"/>
+          <p:cNvSpPr txBox="1"/>
+          <p:nvPr/>
+        </p:nvSpPr>
+        <p:spPr>
+          <a:xfrm>
+            <a:off x="2057400" y="3886199"/>
+            <a:ext cx="3840480" cy="868680"/>
+          </a:xfrm>
+          <a:prstGeom prst="rect">
+            <a:avLst/>
+          </a:prstGeom>
+          <a:noFill/>
+        </p:spPr>
+        <p:txBody>
+          <a:bodyPr wrap="square" lIns="0" rIns="0" tIns="0" bIns="0" anchor="t">
+            <a:spAutoFit/>
+          </a:bodyPr>
+          <a:lstStyle/>
+          <a:p>
+            <a:pPr algn="l"/>
+            <a:r>
+              <a:rPr sz="1200" b="1" i="0">
+                <a:solidFill>
+                  <a:srgbClr val="FFFFFF"/>
+                </a:solidFill>
+                <a:latin typeface="Calibri"/>
+              </a:rPr>
+              <a:t>Accuracy and MCC fall below the image-split baseline, and fold-to-fold spread widens.</a:t>
+            </a:r>
+          </a:p>
+        </p:txBody>
+      </p:sp>
+      <p:sp>
+        <p:nvSpPr>
+          <p:cNvPr id="16" name="TextBox 15"/>
+          <p:cNvSpPr txBox="1"/>
+          <p:nvPr/>
+        </p:nvSpPr>
+        <p:spPr>
+          <a:xfrm>
+            <a:off x="932688" y="4809744"/>
+            <a:ext cx="1188720" cy="274320"/>
+          </a:xfrm>
+          <a:prstGeom prst="rect">
+            <a:avLst/>
+          </a:prstGeom>
+          <a:noFill/>
+        </p:spPr>
+        <p:txBody>
+          <a:bodyPr wrap="square" lIns="0" rIns="0" tIns="0" bIns="0" anchor="t">
+            <a:spAutoFit/>
+          </a:bodyPr>
+          <a:lstStyle/>
+          <a:p>
+            <a:pPr algn="l"/>
+            <a:r>
+              <a:rPr sz="1050" b="1" i="0">
+                <a:solidFill>
+                  <a:srgbClr val="9FC0C9"/>
+                </a:solidFill>
+                <a:latin typeface="Calibri"/>
+              </a:rPr>
+              <a:t>BECAUSE</a:t>
+            </a:r>
+          </a:p>
+        </p:txBody>
+      </p:sp>
+      <p:sp>
+        <p:nvSpPr>
+          <p:cNvPr id="17" name="TextBox 16"/>
+          <p:cNvSpPr txBox="1"/>
+          <p:nvPr/>
+        </p:nvSpPr>
+        <p:spPr>
+          <a:xfrm>
+            <a:off x="2057400" y="4782312"/>
+            <a:ext cx="3840480" cy="868680"/>
+          </a:xfrm>
+          <a:prstGeom prst="rect">
+            <a:avLst/>
+          </a:prstGeom>
+          <a:noFill/>
+        </p:spPr>
+        <p:txBody>
+          <a:bodyPr wrap="square" lIns="0" rIns="0" tIns="0" bIns="0" anchor="t">
+            <a:spAutoFit/>
+          </a:bodyPr>
+          <a:lstStyle/>
+          <a:p>
+            <a:pPr algn="l"/>
+            <a:r>
+              <a:rPr sz="1200" b="0" i="0">
+                <a:solidFill>
+                  <a:srgbClr val="D5E6EA"/>
+                </a:solidFill>
+                <a:latin typeface="Calibri"/>
+              </a:rPr>
+              <a:t>Cells from one slide share stain, lighting and the patient's cell shape. A random split lets the model recognise the slide rather than the parasite.</a:t>
+            </a:r>
+          </a:p>
+        </p:txBody>
+      </p:sp>
+      <p:sp>
+        <p:nvSpPr>
+          <p:cNvPr id="18" name="Rounded Rectangle 17"/>
+          <p:cNvSpPr/>
+          <p:nvPr/>
+        </p:nvSpPr>
+        <p:spPr>
+          <a:xfrm>
+            <a:off x="6345936" y="1828800"/>
+            <a:ext cx="5468112" cy="3931920"/>
+          </a:xfrm>
+          <a:prstGeom prst="roundRect">
+            <a:avLst>
+              <a:gd name="adj" fmla="val 6000"/>
+            </a:avLst>
+          </a:prstGeom>
+          <a:solidFill>
+            <a:srgbClr val="15455A"/>
+          </a:solidFill>
+          <a:ln w="12700">
+            <a:solidFill>
+              <a:srgbClr val="0E6274"/>
+            </a:solidFill>
+          </a:ln>
+          <a:effectLst/>
+        </p:spPr>
+        <p:style>
+          <a:lnRef idx="1">
+            <a:schemeClr val="accent1"/>
+          </a:lnRef>
+          <a:fillRef idx="3">
+            <a:schemeClr val="accent1"/>
+          </a:fillRef>
+          <a:effectRef idx="2">
+            <a:schemeClr val="accent1"/>
+          </a:effectRef>
+          <a:fontRef idx="minor">
+            <a:schemeClr val="lt1"/>
+          </a:fontRef>
+        </p:style>
+        <p:txBody>
+          <a:bodyPr rtlCol="0" anchor="ctr"/>
+          <a:lstStyle/>
+          <a:p/>
+        </p:txBody>
+      </p:sp>
+      <p:sp>
+        <p:nvSpPr>
+          <p:cNvPr id="19" name="Oval 18"/>
+          <p:cNvSpPr/>
+          <p:nvPr/>
+        </p:nvSpPr>
+        <p:spPr>
+          <a:xfrm>
+            <a:off x="6620256" y="2057400"/>
+            <a:ext cx="731520" cy="731520"/>
+          </a:xfrm>
+          <a:prstGeom prst="ellipse">
+            <a:avLst/>
+          </a:prstGeom>
+          <a:solidFill>
+            <a:srgbClr val="2EA79B"/>
+          </a:solidFill>
+          <a:ln>
+            <a:noFill/>
+          </a:ln>
+          <a:effectLst/>
+        </p:spPr>
+        <p:style>
+          <a:lnRef idx="1">
+            <a:schemeClr val="accent1"/>
+          </a:lnRef>
+          <a:fillRef idx="3">
+            <a:schemeClr val="accent1"/>
+          </a:fillRef>
+          <a:effectRef idx="2">
+            <a:schemeClr val="accent1"/>
+          </a:effectRef>
+          <a:fontRef idx="minor">
+            <a:schemeClr val="lt1"/>
+          </a:fontRef>
+        </p:style>
+        <p:txBody>
+          <a:bodyPr rtlCol="0" anchor="ctr"/>
+          <a:lstStyle/>
+          <a:p/>
+        </p:txBody>
+      </p:sp>
+      <p:pic>
+        <p:nvPicPr>
           <p:cNvPr id="20" name="Picture 19" descr="image.png"/>
           <p:cNvPicPr>
             <a:picLocks noChangeAspect="1"/>
@@ -20373,7 +20999,7 @@
 </p:sld>
 </file>
 
-<file path=ppt/slides/slide21.xml><?xml version="1.0" encoding="utf-8"?>
+<file path=ppt/slides/slide22.xml><?xml version="1.0" encoding="utf-8"?>
 <p:sld xmlns:a="http://schemas.openxmlformats.org/drawingml/2006/main" xmlns:p="http://schemas.openxmlformats.org/presentationml/2006/main" xmlns:r="http://schemas.openxmlformats.org/officeDocument/2006/relationships">
   <p:cSld>
     <p:spTree>
@@ -21701,7 +22327,7 @@
 </p:sld>
 </file>
 
-<file path=ppt/slides/slide22.xml><?xml version="1.0" encoding="utf-8"?>
+<file path=ppt/slides/slide23.xml><?xml version="1.0" encoding="utf-8"?>
 <p:sld xmlns:a="http://schemas.openxmlformats.org/drawingml/2006/main" xmlns:r="http://schemas.openxmlformats.org/officeDocument/2006/relationships" xmlns:p="http://schemas.openxmlformats.org/presentationml/2006/main">
   <p:cSld name="Slide 16">
     <p:spTree>
@@ -22337,542 +22963,6 @@
               <a:t>23</a:t>
             </a:r>
             <a:endParaRPr lang="en-US" sz="1000" dirty="0"/>
-          </a:p>
-        </p:txBody>
-      </p:sp>
-    </p:spTree>
-  </p:cSld>
-  <p:clrMapOvr>
-    <a:masterClrMapping/>
-  </p:clrMapOvr>
-</p:sld>
-</file>
-
-<file path=ppt/slides/slide23.xml><?xml version="1.0" encoding="utf-8"?>
-<p:sld xmlns:a="http://schemas.openxmlformats.org/drawingml/2006/main" xmlns:p="http://schemas.openxmlformats.org/presentationml/2006/main" xmlns:r="http://schemas.openxmlformats.org/officeDocument/2006/relationships">
-  <p:cSld>
-    <p:spTree>
-      <p:nvGrpSpPr>
-        <p:cNvPr id="2" name=""/>
-        <p:cNvGrpSpPr/>
-        <p:nvPr/>
-      </p:nvGrpSpPr>
-      <p:grpSpPr/>
-      <p:sp>
-        <p:nvSpPr>
-          <p:cNvPr id="3" name="TextBox 1"/>
-          <p:cNvSpPr txBox="1"/>
-          <p:nvPr/>
-        </p:nvSpPr>
-        <p:spPr>
-          <a:xfrm>
-            <a:off x="548640" y="457200"/>
-            <a:ext cx="11064240" cy="274320"/>
-          </a:xfrm>
-          <a:prstGeom prst="rect">
-            <a:avLst/>
-          </a:prstGeom>
-          <a:noFill/>
-        </p:spPr>
-        <p:txBody>
-          <a:bodyPr wrap="square" lIns="0" rIns="0" tIns="0" bIns="0" anchor="t">
-            <a:spAutoFit/>
-          </a:bodyPr>
-          <a:lstStyle/>
-          <a:p>
-            <a:pPr algn="l"/>
-            <a:r>
-              <a:rPr sz="1250" b="1" i="0">
-                <a:solidFill>
-                  <a:srgbClr val="137C8E"/>
-                </a:solidFill>
-                <a:latin typeface="Calibri"/>
-              </a:rPr>
-              <a:t>MILESTONE 2 · BASELINE REPRODUCTION</a:t>
-            </a:r>
-          </a:p>
-        </p:txBody>
-      </p:sp>
-      <p:sp>
-        <p:nvSpPr>
-          <p:cNvPr id="4" name="TextBox 2"/>
-          <p:cNvSpPr txBox="1"/>
-          <p:nvPr/>
-        </p:nvSpPr>
-        <p:spPr>
-          <a:xfrm>
-            <a:off x="548640" y="749808"/>
-            <a:ext cx="11064240" cy="658368"/>
-          </a:xfrm>
-          <a:prstGeom prst="rect">
-            <a:avLst/>
-          </a:prstGeom>
-          <a:noFill/>
-        </p:spPr>
-        <p:txBody>
-          <a:bodyPr wrap="square" lIns="0" rIns="0" tIns="0" bIns="0" anchor="t">
-            <a:spAutoFit/>
-          </a:bodyPr>
-          <a:lstStyle/>
-          <a:p>
-            <a:pPr algn="l"/>
-            <a:r>
-              <a:rPr sz="3000" b="1" i="0">
-                <a:solidFill>
-                  <a:srgbClr val="17262E"/>
-                </a:solidFill>
-                <a:latin typeface="Cambria"/>
-              </a:rPr>
-              <a:t>A0 results at a glance</a:t>
-            </a:r>
-          </a:p>
-        </p:txBody>
-      </p:sp>
-      <p:sp>
-        <p:nvSpPr>
-          <p:cNvPr id="5" name="TextBox 3"/>
-          <p:cNvSpPr txBox="1"/>
-          <p:nvPr/>
-        </p:nvSpPr>
-        <p:spPr>
-          <a:xfrm>
-            <a:off x="548640" y="1463040"/>
-            <a:ext cx="11064240" cy="457200"/>
-          </a:xfrm>
-          <a:prstGeom prst="rect">
-            <a:avLst/>
-          </a:prstGeom>
-          <a:noFill/>
-        </p:spPr>
-        <p:txBody>
-          <a:bodyPr wrap="square" lIns="0" rIns="0" tIns="0" bIns="0" anchor="t">
-            <a:spAutoFit/>
-          </a:bodyPr>
-          <a:lstStyle/>
-          <a:p>
-            <a:pPr algn="l"/>
-            <a:r>
-              <a:rPr sz="1550" b="0" i="0">
-                <a:solidFill>
-                  <a:srgbClr val="41525B"/>
-                </a:solidFill>
-                <a:latin typeface="Calibri"/>
-              </a:rPr>
-              <a:t>Ensemble of our 3 fold models on the 2,756-image hold-out test set, next to what Marques et al. [8] report.</a:t>
-            </a:r>
-          </a:p>
-        </p:txBody>
-      </p:sp>
-      <p:sp>
-        <p:nvSpPr>
-          <p:cNvPr id="6" name="Rounded Rectangle 6"/>
-          <p:cNvSpPr/>
-          <p:nvPr/>
-        </p:nvSpPr>
-        <p:spPr>
-          <a:xfrm>
-            <a:off x="548640" y="2057400"/>
-            <a:ext cx="4454730" cy="2312244"/>
-          </a:xfrm>
-          <a:prstGeom prst="roundRect">
-            <a:avLst>
-              <a:gd name="adj" fmla="val 6000"/>
-            </a:avLst>
-          </a:prstGeom>
-          <a:solidFill>
-            <a:srgbClr val="EAF3F5"/>
-          </a:solidFill>
-          <a:ln w="12700">
-            <a:solidFill>
-              <a:srgbClr val="D3E1E6"/>
-            </a:solidFill>
-          </a:ln>
-          <a:effectLst/>
-        </p:spPr>
-        <p:style>
-          <a:lnRef idx="1">
-            <a:schemeClr val="accent1"/>
-          </a:lnRef>
-          <a:fillRef idx="3">
-            <a:schemeClr val="accent1"/>
-          </a:fillRef>
-          <a:effectRef idx="2">
-            <a:schemeClr val="accent1"/>
-          </a:effectRef>
-          <a:fontRef idx="minor">
-            <a:schemeClr val="lt1"/>
-          </a:fontRef>
-        </p:style>
-        <p:txBody>
-          <a:bodyPr rtlCol="0" anchor="ctr"/>
-          <a:lstStyle/>
-          <a:p/>
-        </p:txBody>
-      </p:sp>
-      <p:sp>
-        <p:nvSpPr>
-          <p:cNvPr id="7" name="TextBox 7"/>
-          <p:cNvSpPr txBox="1"/>
-          <p:nvPr/>
-        </p:nvSpPr>
-        <p:spPr>
-          <a:xfrm>
-            <a:off x="685800" y="2194560"/>
-            <a:ext cx="4180410" cy="274320"/>
-          </a:xfrm>
-          <a:prstGeom prst="rect">
-            <a:avLst/>
-          </a:prstGeom>
-          <a:noFill/>
-        </p:spPr>
-        <p:txBody>
-          <a:bodyPr wrap="square" lIns="0" rIns="0" tIns="0" bIns="0" anchor="t">
-            <a:spAutoFit/>
-          </a:bodyPr>
-          <a:lstStyle/>
-          <a:p>
-            <a:pPr algn="l"/>
-            <a:r>
-              <a:rPr sz="1100" b="1" i="0">
-                <a:solidFill>
-                  <a:srgbClr val="137C8E"/>
-                </a:solidFill>
-                <a:latin typeface="Calibri"/>
-              </a:rPr>
-              <a:t>PAPER VS. OURS</a:t>
-            </a:r>
-          </a:p>
-        </p:txBody>
-      </p:sp>
-      <p:pic>
-        <p:nvPicPr>
-          <p:cNvPr id="8" name="Figure Paper" descr="A0_vs_paper.png"/>
-          <p:cNvPicPr>
-            <a:picLocks noChangeAspect="1"/>
-          </p:cNvPicPr>
-          <p:nvPr/>
-        </p:nvPicPr>
-        <p:blipFill>
-          <a:blip r:embed="rId2"/>
-          <a:stretch>
-            <a:fillRect/>
-          </a:stretch>
-        </p:blipFill>
-        <p:spPr>
-          <a:xfrm>
-            <a:off x="685800" y="2560320"/>
-            <a:ext cx="4180410" cy="1672164"/>
-          </a:xfrm>
-          <a:prstGeom prst="rect">
-            <a:avLst/>
-          </a:prstGeom>
-        </p:spPr>
-      </p:pic>
-      <p:sp>
-        <p:nvSpPr>
-          <p:cNvPr id="9" name="Rounded Rectangle 6"/>
-          <p:cNvSpPr/>
-          <p:nvPr/>
-        </p:nvSpPr>
-        <p:spPr>
-          <a:xfrm>
-            <a:off x="5186250" y="2057400"/>
-            <a:ext cx="6454056" cy="2312244"/>
-          </a:xfrm>
-          <a:prstGeom prst="roundRect">
-            <a:avLst>
-              <a:gd name="adj" fmla="val 6000"/>
-            </a:avLst>
-          </a:prstGeom>
-          <a:solidFill>
-            <a:srgbClr val="EAF3F5"/>
-          </a:solidFill>
-          <a:ln w="12700">
-            <a:solidFill>
-              <a:srgbClr val="D3E1E6"/>
-            </a:solidFill>
-          </a:ln>
-          <a:effectLst/>
-        </p:spPr>
-        <p:style>
-          <a:lnRef idx="1">
-            <a:schemeClr val="accent1"/>
-          </a:lnRef>
-          <a:fillRef idx="3">
-            <a:schemeClr val="accent1"/>
-          </a:fillRef>
-          <a:effectRef idx="2">
-            <a:schemeClr val="accent1"/>
-          </a:effectRef>
-          <a:fontRef idx="minor">
-            <a:schemeClr val="lt1"/>
-          </a:fontRef>
-        </p:style>
-        <p:txBody>
-          <a:bodyPr rtlCol="0" anchor="ctr"/>
-          <a:lstStyle/>
-          <a:p/>
-        </p:txBody>
-      </p:sp>
-      <p:sp>
-        <p:nvSpPr>
-          <p:cNvPr id="10" name="TextBox 7"/>
-          <p:cNvSpPr txBox="1"/>
-          <p:nvPr/>
-        </p:nvSpPr>
-        <p:spPr>
-          <a:xfrm>
-            <a:off x="5323410" y="2194560"/>
-            <a:ext cx="6179736" cy="274320"/>
-          </a:xfrm>
-          <a:prstGeom prst="rect">
-            <a:avLst/>
-          </a:prstGeom>
-          <a:noFill/>
-        </p:spPr>
-        <p:txBody>
-          <a:bodyPr wrap="square" lIns="0" rIns="0" tIns="0" bIns="0" anchor="t">
-            <a:spAutoFit/>
-          </a:bodyPr>
-          <a:lstStyle/>
-          <a:p>
-            <a:pPr algn="l"/>
-            <a:r>
-              <a:rPr sz="1100" b="1" i="0">
-                <a:solidFill>
-                  <a:srgbClr val="137C8E"/>
-                </a:solidFill>
-                <a:latin typeface="Calibri"/>
-              </a:rPr>
-              <a:t>TRAINING CURVES · CONFUSION MATRIX · ROC</a:t>
-            </a:r>
-          </a:p>
-        </p:txBody>
-      </p:sp>
-      <p:pic>
-        <p:nvPicPr>
-          <p:cNvPr id="11" name="Figure Training" descr="A0_curves_cm_roc.png"/>
-          <p:cNvPicPr>
-            <a:picLocks noChangeAspect="1"/>
-          </p:cNvPicPr>
-          <p:nvPr/>
-        </p:nvPicPr>
-        <p:blipFill>
-          <a:blip r:embed="rId3"/>
-          <a:stretch>
-            <a:fillRect/>
-          </a:stretch>
-        </p:blipFill>
-        <p:spPr>
-          <a:xfrm>
-            <a:off x="5323410" y="2560320"/>
-            <a:ext cx="6179736" cy="1672164"/>
-          </a:xfrm>
-          <a:prstGeom prst="rect">
-            <a:avLst/>
-          </a:prstGeom>
-        </p:spPr>
-      </p:pic>
-      <p:sp>
-        <p:nvSpPr>
-          <p:cNvPr id="12" name="Shape 15"/>
-          <p:cNvSpPr/>
-          <p:nvPr/>
-        </p:nvSpPr>
-        <p:spPr>
-          <a:xfrm>
-            <a:off x="548640" y="4689684"/>
-            <a:ext cx="11091672" cy="868680"/>
-          </a:xfrm>
-          <a:prstGeom prst="roundRect">
-            <a:avLst>
-              <a:gd name="adj" fmla="val 10526"/>
-            </a:avLst>
-          </a:prstGeom>
-          <a:solidFill>
-            <a:srgbClr val="0F2E3D"/>
-          </a:solidFill>
-          <a:ln/>
-        </p:spPr>
-        <p:txBody>
-          <a:bodyPr/>
-          <a:p/>
-        </p:txBody>
-      </p:sp>
-      <p:sp>
-        <p:nvSpPr>
-          <p:cNvPr id="13" name="Shape 16"/>
-          <p:cNvSpPr/>
-          <p:nvPr/>
-        </p:nvSpPr>
-        <p:spPr>
-          <a:xfrm>
-            <a:off x="905256" y="4790268"/>
-            <a:ext cx="658368" cy="658368"/>
-          </a:xfrm>
-          <a:prstGeom prst="ellipse">
-            <a:avLst/>
-          </a:prstGeom>
-          <a:solidFill>
-            <a:srgbClr val="2EA79B"/>
-          </a:solidFill>
-          <a:ln/>
-        </p:spPr>
-        <p:txBody>
-          <a:bodyPr/>
-          <a:p/>
-        </p:txBody>
-      </p:sp>
-      <p:pic>
-        <p:nvPicPr>
-          <p:cNvPr id="14" name="Image 3" descr="/tmp/build/assets/ic_bolt.png">    </p:cNvPr>
-          <p:cNvPicPr>
-            <a:picLocks noChangeAspect="1"/>
-          </p:cNvPicPr>
-          <p:nvPr/>
-        </p:nvPicPr>
-        <p:blipFill>
-          <a:blip r:embed="rId4"/>
-          <a:stretch>
-            <a:fillRect/>
-          </a:stretch>
-        </p:blipFill>
-        <p:spPr>
-          <a:xfrm>
-            <a:off x="1069848" y="4954860"/>
-            <a:ext cx="329184" cy="329184"/>
-          </a:xfrm>
-          <a:prstGeom prst="rect">
-            <a:avLst/>
-          </a:prstGeom>
-        </p:spPr>
-      </p:pic>
-      <p:sp>
-        <p:nvSpPr>
-          <p:cNvPr id="15" name="Text 17"/>
-          <p:cNvSpPr txBox="1"/>
-          <p:nvPr/>
-        </p:nvSpPr>
-        <p:spPr>
-          <a:xfrm>
-            <a:off x="1783080" y="4689684"/>
-            <a:ext cx="9601200" cy="868680"/>
-          </a:xfrm>
-          <a:prstGeom prst="rect">
-            <a:avLst/>
-          </a:prstGeom>
-          <a:noFill/>
-          <a:ln/>
-        </p:spPr>
-        <p:txBody>
-          <a:bodyPr wrap="square" lIns="0" tIns="0" rIns="0" bIns="0" rtlCol="0" anchor="ctr"/>
-          <a:lstStyle/>
-          <a:p>
-            <a:pPr indent="0" marL="0">
-              <a:lnSpc>
-                <a:spcPct val="105000"/>
-              </a:lnSpc>
-              <a:buNone/>
-            </a:pPr>
-            <a:r>
-              <a:rPr lang="en-US" sz="1550" b="1" dirty="0">
-                <a:solidFill>
-                  <a:srgbClr val="2EA79B"/>
-                </a:solidFill>
-                <a:latin typeface="Calibri" pitchFamily="34" charset="0"/>
-                <a:ea typeface="Calibri" pitchFamily="34" charset="-122"/>
-                <a:cs typeface="Calibri" pitchFamily="34" charset="-120"/>
-              </a:rPr>
-              <a:t>Takeaway:  </a:t>
-            </a:r>
-            <a:pPr indent="0" marL="0">
-              <a:lnSpc>
-                <a:spcPct val="105000"/>
-              </a:lnSpc>
-              <a:buNone/>
-            </a:pPr>
-            <a:r>
-              <a:rPr lang="en-US" sz="1550" dirty="0">
-                <a:solidFill>
-                  <a:srgbClr val="E8F2F4"/>
-                </a:solidFill>
-                <a:latin typeface="Calibri" pitchFamily="34" charset="0"/>
-                <a:ea typeface="Calibri" pitchFamily="34" charset="-122"/>
-                <a:cs typeface="Calibri" pitchFamily="34" charset="-120"/>
-              </a:rPr>
-              <a:t>Within 1 pp of the paper on both headline accuracies; recall is 2 pp lower (44 missed infected cells).</a:t>
-            </a:r>
-            <a:endParaRPr lang="en-US" sz="1550" dirty="0"/>
-          </a:p>
-        </p:txBody>
-      </p:sp>
-      <p:sp>
-        <p:nvSpPr>
-          <p:cNvPr id="16" name="TextBox 10"/>
-          <p:cNvSpPr txBox="1"/>
-          <p:nvPr/>
-        </p:nvSpPr>
-        <p:spPr>
-          <a:xfrm>
-            <a:off x="548640" y="6455664"/>
-            <a:ext cx="7315200" cy="274320"/>
-          </a:xfrm>
-          <a:prstGeom prst="rect">
-            <a:avLst/>
-          </a:prstGeom>
-          <a:noFill/>
-        </p:spPr>
-        <p:txBody>
-          <a:bodyPr wrap="square" lIns="0" rIns="0" tIns="0" bIns="0" anchor="t">
-            <a:spAutoFit/>
-          </a:bodyPr>
-          <a:lstStyle/>
-          <a:p>
-            <a:pPr algn="l"/>
-            <a:r>
-              <a:rPr sz="900" b="0" i="0">
-                <a:solidFill>
-                  <a:srgbClr val="7C8B93"/>
-                </a:solidFill>
-                <a:latin typeface="Calibri"/>
-              </a:rPr>
-              <a:t>Phase 2 · Baseline &amp; Hypothesis · Automated Malaria Cell Detection</a:t>
-            </a:r>
-          </a:p>
-        </p:txBody>
-      </p:sp>
-      <p:sp>
-        <p:nvSpPr>
-          <p:cNvPr id="17" name="TextBox 11"/>
-          <p:cNvSpPr txBox="1"/>
-          <p:nvPr/>
-        </p:nvSpPr>
-        <p:spPr>
-          <a:xfrm>
-            <a:off x="11183112" y="6419088"/>
-            <a:ext cx="457200" cy="274320"/>
-          </a:xfrm>
-          <a:prstGeom prst="rect">
-            <a:avLst/>
-          </a:prstGeom>
-          <a:noFill/>
-        </p:spPr>
-        <p:txBody>
-          <a:bodyPr wrap="square" lIns="0" rIns="0" tIns="0" bIns="0" anchor="t">
-            <a:spAutoFit/>
-          </a:bodyPr>
-          <a:lstStyle/>
-          <a:p>
-            <a:pPr algn="r"/>
-            <a:r>
-              <a:rPr sz="1000" b="0" i="0">
-                <a:solidFill>
-                  <a:srgbClr val="7C8B93"/>
-                </a:solidFill>
-                <a:latin typeface="Calibri"/>
-              </a:rPr>
-              <a:t>20</a:t>
-            </a:r>
           </a:p>
         </p:txBody>
       </p:sp>

</xml_diff>

<commit_message>
Slides: per-fold A0 results table
</commit_message>
<xml_diff>
--- a/slides/Malaria_Phase2_Baseline_Hypothesis_filled.pptx
+++ b/slides/Malaria_Phase2_Baseline_Hypothesis_filled.pptx
@@ -25,6 +25,7 @@
     <p:sldId id="273" r:id="rId24"/>
     <p:sldId id="274" r:id="rId25"/>
     <p:sldId id="278" r:id="rId29"/>
+    <p:sldId id="279" r:id="rId30"/>
     <p:sldId id="275" r:id="rId26"/>
     <p:sldId id="276" r:id="rId27"/>
     <p:sldId id="271" r:id="rId17"/>
@@ -22314,7 +22315,7 @@
                 </a:solidFill>
                 <a:latin typeface="Calibri"/>
               </a:rPr>
-              <a:t>22</a:t>
+              <a:t>23</a:t>
             </a:r>
           </a:p>
         </p:txBody>
@@ -22960,9 +22961,1176 @@
                 <a:ea typeface="Calibri" pitchFamily="34" charset="-122"/>
                 <a:cs typeface="Calibri" pitchFamily="34" charset="-120"/>
               </a:rPr>
-              <a:t>23</a:t>
+              <a:t>24</a:t>
             </a:r>
             <a:endParaRPr lang="en-US" sz="1000" dirty="0"/>
+          </a:p>
+        </p:txBody>
+      </p:sp>
+    </p:spTree>
+  </p:cSld>
+  <p:clrMapOvr>
+    <a:masterClrMapping/>
+  </p:clrMapOvr>
+</p:sld>
+</file>
+
+<file path=ppt/slides/slide24.xml><?xml version="1.0" encoding="utf-8"?>
+<p:sld xmlns:a="http://schemas.openxmlformats.org/drawingml/2006/main" xmlns:p="http://schemas.openxmlformats.org/presentationml/2006/main" xmlns:r="http://schemas.openxmlformats.org/officeDocument/2006/relationships">
+  <p:cSld>
+    <p:spTree>
+      <p:nvGrpSpPr>
+        <p:cNvPr id="2" name=""/>
+        <p:cNvGrpSpPr/>
+        <p:nvPr/>
+      </p:nvGrpSpPr>
+      <p:grpSpPr/>
+      <p:sp>
+        <p:nvSpPr>
+          <p:cNvPr id="3" name="TextBox 1"/>
+          <p:cNvSpPr txBox="1"/>
+          <p:nvPr/>
+        </p:nvSpPr>
+        <p:spPr>
+          <a:xfrm>
+            <a:off x="548640" y="457200"/>
+            <a:ext cx="11064240" cy="274320"/>
+          </a:xfrm>
+          <a:prstGeom prst="rect">
+            <a:avLst/>
+          </a:prstGeom>
+          <a:noFill/>
+        </p:spPr>
+        <p:txBody>
+          <a:bodyPr wrap="square" lIns="0" rIns="0" tIns="0" bIns="0" anchor="t">
+            <a:spAutoFit/>
+          </a:bodyPr>
+          <a:lstStyle/>
+          <a:p>
+            <a:pPr algn="l"/>
+            <a:r>
+              <a:rPr sz="1250" b="1" i="0">
+                <a:solidFill>
+                  <a:srgbClr val="137C8E"/>
+                </a:solidFill>
+                <a:latin typeface="Calibri"/>
+              </a:rPr>
+              <a:t>MILESTONE 2 · BASELINE REPRODUCTION</a:t>
+            </a:r>
+          </a:p>
+        </p:txBody>
+      </p:sp>
+      <p:sp>
+        <p:nvSpPr>
+          <p:cNvPr id="4" name="TextBox 2"/>
+          <p:cNvSpPr txBox="1"/>
+          <p:nvPr/>
+        </p:nvSpPr>
+        <p:spPr>
+          <a:xfrm>
+            <a:off x="548640" y="749808"/>
+            <a:ext cx="11064240" cy="658368"/>
+          </a:xfrm>
+          <a:prstGeom prst="rect">
+            <a:avLst/>
+          </a:prstGeom>
+          <a:noFill/>
+        </p:spPr>
+        <p:txBody>
+          <a:bodyPr wrap="square" lIns="0" rIns="0" tIns="0" bIns="0" anchor="t">
+            <a:spAutoFit/>
+          </a:bodyPr>
+          <a:lstStyle/>
+          <a:p>
+            <a:pPr algn="l"/>
+            <a:r>
+              <a:rPr sz="3000" b="1" i="0">
+                <a:solidFill>
+                  <a:srgbClr val="17262E"/>
+                </a:solidFill>
+                <a:latin typeface="Cambria"/>
+              </a:rPr>
+              <a:t>A0 per-fold results</a:t>
+            </a:r>
+          </a:p>
+        </p:txBody>
+      </p:sp>
+      <p:sp>
+        <p:nvSpPr>
+          <p:cNvPr id="5" name="TextBox 3"/>
+          <p:cNvSpPr txBox="1"/>
+          <p:nvPr/>
+        </p:nvSpPr>
+        <p:spPr>
+          <a:xfrm>
+            <a:off x="548640" y="1463040"/>
+            <a:ext cx="11064240" cy="457200"/>
+          </a:xfrm>
+          <a:prstGeom prst="rect">
+            <a:avLst/>
+          </a:prstGeom>
+          <a:noFill/>
+        </p:spPr>
+        <p:txBody>
+          <a:bodyPr wrap="square" lIns="0" rIns="0" tIns="0" bIns="0" anchor="t">
+            <a:spAutoFit/>
+          </a:bodyPr>
+          <a:lstStyle/>
+          <a:p>
+            <a:pPr algn="l"/>
+            <a:r>
+              <a:rPr sz="1550" b="0" i="0">
+                <a:solidFill>
+                  <a:srgbClr val="41525B"/>
+                </a:solidFill>
+                <a:latin typeface="Calibri"/>
+              </a:rPr>
+              <a:t>Each fold model scored on its own validation split (2,481 cells). Last row: mean ± SD over the 3 folds. MCC as a coefficient (0–1).</a:t>
+            </a:r>
+          </a:p>
+        </p:txBody>
+      </p:sp>
+      <p:graphicFrame>
+        <p:nvGraphicFramePr>
+          <p:cNvPr id="6" name="Table 8"/>
+          <p:cNvGraphicFramePr>
+            <a:graphicFrameLocks noGrp="1"/>
+          </p:cNvGraphicFramePr>
+          <p:nvPr/>
+        </p:nvGraphicFramePr>
+        <p:xfrm>
+          <a:off x="548640" y="2103120"/>
+          <a:ext cx="11091672" cy="2286000"/>
+        </p:xfrm>
+        <a:graphic>
+          <a:graphicData uri="http://schemas.openxmlformats.org/drawingml/2006/table">
+            <a:tbl>
+              <a:tblPr firstRow="1" bandRow="0">
+                <a:tableStyleId>{5C22544A-7EE6-4342-B048-85BDC9FD1C3A}</a:tableStyleId>
+              </a:tblPr>
+              <a:tblGrid>
+                <a:gridCol w="1645920"/>
+                <a:gridCol w="1574292"/>
+                <a:gridCol w="1574292"/>
+                <a:gridCol w="1574292"/>
+                <a:gridCol w="1574292"/>
+                <a:gridCol w="1574292"/>
+                <a:gridCol w="1574292"/>
+              </a:tblGrid>
+              <a:tr h="457200">
+                <a:tc>
+                  <a:txBody>
+                    <a:bodyPr wrap="square"/>
+                    <a:lstStyle/>
+                    <a:p>
+                      <a:r>
+                        <a:rPr sz="1400" b="1">
+                          <a:solidFill>
+                            <a:srgbClr val="FFFFFF"/>
+                          </a:solidFill>
+                          <a:latin typeface="Calibri"/>
+                        </a:rPr>
+                        <a:t>Fold</a:t>
+                      </a:r>
+                    </a:p>
+                  </a:txBody>
+                  <a:tcPr marL="73152" marR="73152" marT="27432" marB="27432" anchor="ctr">
+                    <a:solidFill>
+                      <a:srgbClr val="17262E"/>
+                    </a:solidFill>
+                  </a:tcPr>
+                </a:tc>
+                <a:tc>
+                  <a:txBody>
+                    <a:bodyPr wrap="square"/>
+                    <a:lstStyle/>
+                    <a:p>
+                      <a:pPr algn="ctr"/>
+                      <a:r>
+                        <a:rPr sz="1400" b="1">
+                          <a:solidFill>
+                            <a:srgbClr val="FFFFFF"/>
+                          </a:solidFill>
+                          <a:latin typeface="Calibri"/>
+                        </a:rPr>
+                        <a:t>Epochs</a:t>
+                      </a:r>
+                    </a:p>
+                  </a:txBody>
+                  <a:tcPr marL="73152" marR="73152" marT="27432" marB="27432" anchor="ctr">
+                    <a:solidFill>
+                      <a:srgbClr val="17262E"/>
+                    </a:solidFill>
+                  </a:tcPr>
+                </a:tc>
+                <a:tc>
+                  <a:txBody>
+                    <a:bodyPr wrap="square"/>
+                    <a:lstStyle/>
+                    <a:p>
+                      <a:pPr algn="ctr"/>
+                      <a:r>
+                        <a:rPr sz="1400" b="1">
+                          <a:solidFill>
+                            <a:srgbClr val="FFFFFF"/>
+                          </a:solidFill>
+                          <a:latin typeface="Calibri"/>
+                        </a:rPr>
+                        <a:t>Minutes</a:t>
+                      </a:r>
+                    </a:p>
+                  </a:txBody>
+                  <a:tcPr marL="73152" marR="73152" marT="27432" marB="27432" anchor="ctr">
+                    <a:solidFill>
+                      <a:srgbClr val="17262E"/>
+                    </a:solidFill>
+                  </a:tcPr>
+                </a:tc>
+                <a:tc>
+                  <a:txBody>
+                    <a:bodyPr wrap="square"/>
+                    <a:lstStyle/>
+                    <a:p>
+                      <a:pPr algn="ctr"/>
+                      <a:r>
+                        <a:rPr sz="1400" b="1">
+                          <a:solidFill>
+                            <a:srgbClr val="FFFFFF"/>
+                          </a:solidFill>
+                          <a:latin typeface="Calibri"/>
+                        </a:rPr>
+                        <a:t>Accuracy</a:t>
+                      </a:r>
+                    </a:p>
+                  </a:txBody>
+                  <a:tcPr marL="73152" marR="73152" marT="27432" marB="27432" anchor="ctr">
+                    <a:solidFill>
+                      <a:srgbClr val="17262E"/>
+                    </a:solidFill>
+                  </a:tcPr>
+                </a:tc>
+                <a:tc>
+                  <a:txBody>
+                    <a:bodyPr wrap="square"/>
+                    <a:lstStyle/>
+                    <a:p>
+                      <a:pPr algn="ctr"/>
+                      <a:r>
+                        <a:rPr sz="1400" b="1">
+                          <a:solidFill>
+                            <a:srgbClr val="FFFFFF"/>
+                          </a:solidFill>
+                          <a:latin typeface="Calibri"/>
+                        </a:rPr>
+                        <a:t>Recall</a:t>
+                      </a:r>
+                    </a:p>
+                  </a:txBody>
+                  <a:tcPr marL="73152" marR="73152" marT="27432" marB="27432" anchor="ctr">
+                    <a:solidFill>
+                      <a:srgbClr val="17262E"/>
+                    </a:solidFill>
+                  </a:tcPr>
+                </a:tc>
+                <a:tc>
+                  <a:txBody>
+                    <a:bodyPr wrap="square"/>
+                    <a:lstStyle/>
+                    <a:p>
+                      <a:pPr algn="ctr"/>
+                      <a:r>
+                        <a:rPr sz="1400" b="1">
+                          <a:solidFill>
+                            <a:srgbClr val="FFFFFF"/>
+                          </a:solidFill>
+                          <a:latin typeface="Calibri"/>
+                        </a:rPr>
+                        <a:t>Precision</a:t>
+                      </a:r>
+                    </a:p>
+                  </a:txBody>
+                  <a:tcPr marL="73152" marR="73152" marT="27432" marB="27432" anchor="ctr">
+                    <a:solidFill>
+                      <a:srgbClr val="17262E"/>
+                    </a:solidFill>
+                  </a:tcPr>
+                </a:tc>
+                <a:tc>
+                  <a:txBody>
+                    <a:bodyPr wrap="square"/>
+                    <a:lstStyle/>
+                    <a:p>
+                      <a:pPr algn="ctr"/>
+                      <a:r>
+                        <a:rPr sz="1400" b="1">
+                          <a:solidFill>
+                            <a:srgbClr val="FFFFFF"/>
+                          </a:solidFill>
+                          <a:latin typeface="Calibri"/>
+                        </a:rPr>
+                        <a:t>MCC</a:t>
+                      </a:r>
+                    </a:p>
+                  </a:txBody>
+                  <a:tcPr marL="73152" marR="73152" marT="27432" marB="27432" anchor="ctr">
+                    <a:solidFill>
+                      <a:srgbClr val="17262E"/>
+                    </a:solidFill>
+                  </a:tcPr>
+                </a:tc>
+              </a:tr>
+              <a:tr h="457200">
+                <a:tc>
+                  <a:txBody>
+                    <a:bodyPr wrap="square"/>
+                    <a:lstStyle/>
+                    <a:p>
+                      <a:r>
+                        <a:rPr sz="1400" b="1">
+                          <a:solidFill>
+                            <a:srgbClr val="17262E"/>
+                          </a:solidFill>
+                          <a:latin typeface="Calibri"/>
+                        </a:rPr>
+                        <a:t>Fold 1</a:t>
+                      </a:r>
+                    </a:p>
+                  </a:txBody>
+                  <a:tcPr marL="73152" marR="73152" marT="27432" marB="27432" anchor="ctr">
+                    <a:solidFill>
+                      <a:srgbClr val="FFFFFF"/>
+                    </a:solidFill>
+                  </a:tcPr>
+                </a:tc>
+                <a:tc>
+                  <a:txBody>
+                    <a:bodyPr wrap="square"/>
+                    <a:lstStyle/>
+                    <a:p>
+                      <a:pPr algn="ctr"/>
+                      <a:r>
+                        <a:rPr sz="1400" b="0">
+                          <a:solidFill>
+                            <a:srgbClr val="41525B"/>
+                          </a:solidFill>
+                          <a:latin typeface="Calibri"/>
+                        </a:rPr>
+                        <a:t>9</a:t>
+                      </a:r>
+                    </a:p>
+                  </a:txBody>
+                  <a:tcPr marL="73152" marR="73152" marT="27432" marB="27432" anchor="ctr">
+                    <a:solidFill>
+                      <a:srgbClr val="FFFFFF"/>
+                    </a:solidFill>
+                  </a:tcPr>
+                </a:tc>
+                <a:tc>
+                  <a:txBody>
+                    <a:bodyPr wrap="square"/>
+                    <a:lstStyle/>
+                    <a:p>
+                      <a:pPr algn="ctr"/>
+                      <a:r>
+                        <a:rPr sz="1400" b="0">
+                          <a:solidFill>
+                            <a:srgbClr val="41525B"/>
+                          </a:solidFill>
+                          <a:latin typeface="Calibri"/>
+                        </a:rPr>
+                        <a:t>20.7</a:t>
+                      </a:r>
+                    </a:p>
+                  </a:txBody>
+                  <a:tcPr marL="73152" marR="73152" marT="27432" marB="27432" anchor="ctr">
+                    <a:solidFill>
+                      <a:srgbClr val="FFFFFF"/>
+                    </a:solidFill>
+                  </a:tcPr>
+                </a:tc>
+                <a:tc>
+                  <a:txBody>
+                    <a:bodyPr wrap="square"/>
+                    <a:lstStyle/>
+                    <a:p>
+                      <a:pPr algn="ctr"/>
+                      <a:r>
+                        <a:rPr sz="1400" b="0">
+                          <a:solidFill>
+                            <a:srgbClr val="41525B"/>
+                          </a:solidFill>
+                          <a:latin typeface="Calibri"/>
+                        </a:rPr>
+                        <a:t>96.57 %</a:t>
+                      </a:r>
+                    </a:p>
+                  </a:txBody>
+                  <a:tcPr marL="73152" marR="73152" marT="27432" marB="27432" anchor="ctr">
+                    <a:solidFill>
+                      <a:srgbClr val="FFFFFF"/>
+                    </a:solidFill>
+                  </a:tcPr>
+                </a:tc>
+                <a:tc>
+                  <a:txBody>
+                    <a:bodyPr wrap="square"/>
+                    <a:lstStyle/>
+                    <a:p>
+                      <a:pPr algn="ctr"/>
+                      <a:r>
+                        <a:rPr sz="1400" b="1">
+                          <a:solidFill>
+                            <a:srgbClr val="D99A00"/>
+                          </a:solidFill>
+                          <a:latin typeface="Calibri"/>
+                        </a:rPr>
+                        <a:t>94.84 %</a:t>
+                      </a:r>
+                    </a:p>
+                  </a:txBody>
+                  <a:tcPr marL="73152" marR="73152" marT="27432" marB="27432" anchor="ctr">
+                    <a:solidFill>
+                      <a:srgbClr val="FFFFFF"/>
+                    </a:solidFill>
+                  </a:tcPr>
+                </a:tc>
+                <a:tc>
+                  <a:txBody>
+                    <a:bodyPr wrap="square"/>
+                    <a:lstStyle/>
+                    <a:p>
+                      <a:pPr algn="ctr"/>
+                      <a:r>
+                        <a:rPr sz="1400" b="0">
+                          <a:solidFill>
+                            <a:srgbClr val="41525B"/>
+                          </a:solidFill>
+                          <a:latin typeface="Calibri"/>
+                        </a:rPr>
+                        <a:t>98.25 %</a:t>
+                      </a:r>
+                    </a:p>
+                  </a:txBody>
+                  <a:tcPr marL="73152" marR="73152" marT="27432" marB="27432" anchor="ctr">
+                    <a:solidFill>
+                      <a:srgbClr val="FFFFFF"/>
+                    </a:solidFill>
+                  </a:tcPr>
+                </a:tc>
+                <a:tc>
+                  <a:txBody>
+                    <a:bodyPr wrap="square"/>
+                    <a:lstStyle/>
+                    <a:p>
+                      <a:pPr algn="ctr"/>
+                      <a:r>
+                        <a:rPr sz="1400" b="0">
+                          <a:solidFill>
+                            <a:srgbClr val="41525B"/>
+                          </a:solidFill>
+                          <a:latin typeface="Calibri"/>
+                        </a:rPr>
+                        <a:t>0.93</a:t>
+                      </a:r>
+                    </a:p>
+                  </a:txBody>
+                  <a:tcPr marL="73152" marR="73152" marT="27432" marB="27432" anchor="ctr">
+                    <a:solidFill>
+                      <a:srgbClr val="FFFFFF"/>
+                    </a:solidFill>
+                  </a:tcPr>
+                </a:tc>
+              </a:tr>
+              <a:tr h="457200">
+                <a:tc>
+                  <a:txBody>
+                    <a:bodyPr wrap="square"/>
+                    <a:lstStyle/>
+                    <a:p>
+                      <a:r>
+                        <a:rPr sz="1400" b="1">
+                          <a:solidFill>
+                            <a:srgbClr val="17262E"/>
+                          </a:solidFill>
+                          <a:latin typeface="Calibri"/>
+                        </a:rPr>
+                        <a:t>Fold 2</a:t>
+                      </a:r>
+                    </a:p>
+                  </a:txBody>
+                  <a:tcPr marL="73152" marR="73152" marT="27432" marB="27432" anchor="ctr">
+                    <a:solidFill>
+                      <a:srgbClr val="F5F9FA"/>
+                    </a:solidFill>
+                  </a:tcPr>
+                </a:tc>
+                <a:tc>
+                  <a:txBody>
+                    <a:bodyPr wrap="square"/>
+                    <a:lstStyle/>
+                    <a:p>
+                      <a:pPr algn="ctr"/>
+                      <a:r>
+                        <a:rPr sz="1400" b="0">
+                          <a:solidFill>
+                            <a:srgbClr val="41525B"/>
+                          </a:solidFill>
+                          <a:latin typeface="Calibri"/>
+                        </a:rPr>
+                        <a:t>10</a:t>
+                      </a:r>
+                    </a:p>
+                  </a:txBody>
+                  <a:tcPr marL="73152" marR="73152" marT="27432" marB="27432" anchor="ctr">
+                    <a:solidFill>
+                      <a:srgbClr val="F5F9FA"/>
+                    </a:solidFill>
+                  </a:tcPr>
+                </a:tc>
+                <a:tc>
+                  <a:txBody>
+                    <a:bodyPr wrap="square"/>
+                    <a:lstStyle/>
+                    <a:p>
+                      <a:pPr algn="ctr"/>
+                      <a:r>
+                        <a:rPr sz="1400" b="0">
+                          <a:solidFill>
+                            <a:srgbClr val="41525B"/>
+                          </a:solidFill>
+                          <a:latin typeface="Calibri"/>
+                        </a:rPr>
+                        <a:t>21.9</a:t>
+                      </a:r>
+                    </a:p>
+                  </a:txBody>
+                  <a:tcPr marL="73152" marR="73152" marT="27432" marB="27432" anchor="ctr">
+                    <a:solidFill>
+                      <a:srgbClr val="F5F9FA"/>
+                    </a:solidFill>
+                  </a:tcPr>
+                </a:tc>
+                <a:tc>
+                  <a:txBody>
+                    <a:bodyPr wrap="square"/>
+                    <a:lstStyle/>
+                    <a:p>
+                      <a:pPr algn="ctr"/>
+                      <a:r>
+                        <a:rPr sz="1400" b="0">
+                          <a:solidFill>
+                            <a:srgbClr val="41525B"/>
+                          </a:solidFill>
+                          <a:latin typeface="Calibri"/>
+                        </a:rPr>
+                        <a:t>98.02 %</a:t>
+                      </a:r>
+                    </a:p>
+                  </a:txBody>
+                  <a:tcPr marL="73152" marR="73152" marT="27432" marB="27432" anchor="ctr">
+                    <a:solidFill>
+                      <a:srgbClr val="F5F9FA"/>
+                    </a:solidFill>
+                  </a:tcPr>
+                </a:tc>
+                <a:tc>
+                  <a:txBody>
+                    <a:bodyPr wrap="square"/>
+                    <a:lstStyle/>
+                    <a:p>
+                      <a:pPr algn="ctr"/>
+                      <a:r>
+                        <a:rPr sz="1400" b="0">
+                          <a:solidFill>
+                            <a:srgbClr val="41525B"/>
+                          </a:solidFill>
+                          <a:latin typeface="Calibri"/>
+                        </a:rPr>
+                        <a:t>97.90 %</a:t>
+                      </a:r>
+                    </a:p>
+                  </a:txBody>
+                  <a:tcPr marL="73152" marR="73152" marT="27432" marB="27432" anchor="ctr">
+                    <a:solidFill>
+                      <a:srgbClr val="F5F9FA"/>
+                    </a:solidFill>
+                  </a:tcPr>
+                </a:tc>
+                <a:tc>
+                  <a:txBody>
+                    <a:bodyPr wrap="square"/>
+                    <a:lstStyle/>
+                    <a:p>
+                      <a:pPr algn="ctr"/>
+                      <a:r>
+                        <a:rPr sz="1400" b="0">
+                          <a:solidFill>
+                            <a:srgbClr val="41525B"/>
+                          </a:solidFill>
+                          <a:latin typeface="Calibri"/>
+                        </a:rPr>
+                        <a:t>98.14 %</a:t>
+                      </a:r>
+                    </a:p>
+                  </a:txBody>
+                  <a:tcPr marL="73152" marR="73152" marT="27432" marB="27432" anchor="ctr">
+                    <a:solidFill>
+                      <a:srgbClr val="F5F9FA"/>
+                    </a:solidFill>
+                  </a:tcPr>
+                </a:tc>
+                <a:tc>
+                  <a:txBody>
+                    <a:bodyPr wrap="square"/>
+                    <a:lstStyle/>
+                    <a:p>
+                      <a:pPr algn="ctr"/>
+                      <a:r>
+                        <a:rPr sz="1400" b="0">
+                          <a:solidFill>
+                            <a:srgbClr val="41525B"/>
+                          </a:solidFill>
+                          <a:latin typeface="Calibri"/>
+                        </a:rPr>
+                        <a:t>0.96</a:t>
+                      </a:r>
+                    </a:p>
+                  </a:txBody>
+                  <a:tcPr marL="73152" marR="73152" marT="27432" marB="27432" anchor="ctr">
+                    <a:solidFill>
+                      <a:srgbClr val="F5F9FA"/>
+                    </a:solidFill>
+                  </a:tcPr>
+                </a:tc>
+              </a:tr>
+              <a:tr h="457200">
+                <a:tc>
+                  <a:txBody>
+                    <a:bodyPr wrap="square"/>
+                    <a:lstStyle/>
+                    <a:p>
+                      <a:r>
+                        <a:rPr sz="1400" b="1">
+                          <a:solidFill>
+                            <a:srgbClr val="17262E"/>
+                          </a:solidFill>
+                          <a:latin typeface="Calibri"/>
+                        </a:rPr>
+                        <a:t>Fold 3</a:t>
+                      </a:r>
+                    </a:p>
+                  </a:txBody>
+                  <a:tcPr marL="73152" marR="73152" marT="27432" marB="27432" anchor="ctr">
+                    <a:solidFill>
+                      <a:srgbClr val="FFFFFF"/>
+                    </a:solidFill>
+                  </a:tcPr>
+                </a:tc>
+                <a:tc>
+                  <a:txBody>
+                    <a:bodyPr wrap="square"/>
+                    <a:lstStyle/>
+                    <a:p>
+                      <a:pPr algn="ctr"/>
+                      <a:r>
+                        <a:rPr sz="1400" b="0">
+                          <a:solidFill>
+                            <a:srgbClr val="41525B"/>
+                          </a:solidFill>
+                          <a:latin typeface="Calibri"/>
+                        </a:rPr>
+                        <a:t>10</a:t>
+                      </a:r>
+                    </a:p>
+                  </a:txBody>
+                  <a:tcPr marL="73152" marR="73152" marT="27432" marB="27432" anchor="ctr">
+                    <a:solidFill>
+                      <a:srgbClr val="FFFFFF"/>
+                    </a:solidFill>
+                  </a:tcPr>
+                </a:tc>
+                <a:tc>
+                  <a:txBody>
+                    <a:bodyPr wrap="square"/>
+                    <a:lstStyle/>
+                    <a:p>
+                      <a:pPr algn="ctr"/>
+                      <a:r>
+                        <a:rPr sz="1400" b="0">
+                          <a:solidFill>
+                            <a:srgbClr val="41525B"/>
+                          </a:solidFill>
+                          <a:latin typeface="Calibri"/>
+                        </a:rPr>
+                        <a:t>21.7</a:t>
+                      </a:r>
+                    </a:p>
+                  </a:txBody>
+                  <a:tcPr marL="73152" marR="73152" marT="27432" marB="27432" anchor="ctr">
+                    <a:solidFill>
+                      <a:srgbClr val="FFFFFF"/>
+                    </a:solidFill>
+                  </a:tcPr>
+                </a:tc>
+                <a:tc>
+                  <a:txBody>
+                    <a:bodyPr wrap="square"/>
+                    <a:lstStyle/>
+                    <a:p>
+                      <a:pPr algn="ctr"/>
+                      <a:r>
+                        <a:rPr sz="1400" b="0">
+                          <a:solidFill>
+                            <a:srgbClr val="41525B"/>
+                          </a:solidFill>
+                          <a:latin typeface="Calibri"/>
+                        </a:rPr>
+                        <a:t>97.54 %</a:t>
+                      </a:r>
+                    </a:p>
+                  </a:txBody>
+                  <a:tcPr marL="73152" marR="73152" marT="27432" marB="27432" anchor="ctr">
+                    <a:solidFill>
+                      <a:srgbClr val="FFFFFF"/>
+                    </a:solidFill>
+                  </a:tcPr>
+                </a:tc>
+                <a:tc>
+                  <a:txBody>
+                    <a:bodyPr wrap="square"/>
+                    <a:lstStyle/>
+                    <a:p>
+                      <a:pPr algn="ctr"/>
+                      <a:r>
+                        <a:rPr sz="1400" b="0">
+                          <a:solidFill>
+                            <a:srgbClr val="41525B"/>
+                          </a:solidFill>
+                          <a:latin typeface="Calibri"/>
+                        </a:rPr>
+                        <a:t>97.18 %</a:t>
+                      </a:r>
+                    </a:p>
+                  </a:txBody>
+                  <a:tcPr marL="73152" marR="73152" marT="27432" marB="27432" anchor="ctr">
+                    <a:solidFill>
+                      <a:srgbClr val="FFFFFF"/>
+                    </a:solidFill>
+                  </a:tcPr>
+                </a:tc>
+                <a:tc>
+                  <a:txBody>
+                    <a:bodyPr wrap="square"/>
+                    <a:lstStyle/>
+                    <a:p>
+                      <a:pPr algn="ctr"/>
+                      <a:r>
+                        <a:rPr sz="1400" b="0">
+                          <a:solidFill>
+                            <a:srgbClr val="41525B"/>
+                          </a:solidFill>
+                          <a:latin typeface="Calibri"/>
+                        </a:rPr>
+                        <a:t>97.89 %</a:t>
+                      </a:r>
+                    </a:p>
+                  </a:txBody>
+                  <a:tcPr marL="73152" marR="73152" marT="27432" marB="27432" anchor="ctr">
+                    <a:solidFill>
+                      <a:srgbClr val="FFFFFF"/>
+                    </a:solidFill>
+                  </a:tcPr>
+                </a:tc>
+                <a:tc>
+                  <a:txBody>
+                    <a:bodyPr wrap="square"/>
+                    <a:lstStyle/>
+                    <a:p>
+                      <a:pPr algn="ctr"/>
+                      <a:r>
+                        <a:rPr sz="1400" b="0">
+                          <a:solidFill>
+                            <a:srgbClr val="41525B"/>
+                          </a:solidFill>
+                          <a:latin typeface="Calibri"/>
+                        </a:rPr>
+                        <a:t>0.95</a:t>
+                      </a:r>
+                    </a:p>
+                  </a:txBody>
+                  <a:tcPr marL="73152" marR="73152" marT="27432" marB="27432" anchor="ctr">
+                    <a:solidFill>
+                      <a:srgbClr val="FFFFFF"/>
+                    </a:solidFill>
+                  </a:tcPr>
+                </a:tc>
+              </a:tr>
+              <a:tr h="457200">
+                <a:tc>
+                  <a:txBody>
+                    <a:bodyPr wrap="square"/>
+                    <a:lstStyle/>
+                    <a:p>
+                      <a:r>
+                        <a:rPr sz="1400" b="1">
+                          <a:solidFill>
+                            <a:srgbClr val="137C8E"/>
+                          </a:solidFill>
+                          <a:latin typeface="Calibri"/>
+                        </a:rPr>
+                        <a:t>Mean ± SD</a:t>
+                      </a:r>
+                    </a:p>
+                  </a:txBody>
+                  <a:tcPr marL="73152" marR="73152" marT="27432" marB="27432" anchor="ctr">
+                    <a:solidFill>
+                      <a:srgbClr val="EAF3F5"/>
+                    </a:solidFill>
+                  </a:tcPr>
+                </a:tc>
+                <a:tc>
+                  <a:txBody>
+                    <a:bodyPr wrap="square"/>
+                    <a:lstStyle/>
+                    <a:p>
+                      <a:pPr algn="ctr"/>
+                      <a:r>
+                        <a:rPr sz="1400" b="1">
+                          <a:solidFill>
+                            <a:srgbClr val="137C8E"/>
+                          </a:solidFill>
+                          <a:latin typeface="Calibri"/>
+                        </a:rPr>
+                        <a:t>—</a:t>
+                      </a:r>
+                    </a:p>
+                  </a:txBody>
+                  <a:tcPr marL="73152" marR="73152" marT="27432" marB="27432" anchor="ctr">
+                    <a:solidFill>
+                      <a:srgbClr val="EAF3F5"/>
+                    </a:solidFill>
+                  </a:tcPr>
+                </a:tc>
+                <a:tc>
+                  <a:txBody>
+                    <a:bodyPr wrap="square"/>
+                    <a:lstStyle/>
+                    <a:p>
+                      <a:pPr algn="ctr"/>
+                      <a:r>
+                        <a:rPr sz="1400" b="1">
+                          <a:solidFill>
+                            <a:srgbClr val="137C8E"/>
+                          </a:solidFill>
+                          <a:latin typeface="Calibri"/>
+                        </a:rPr>
+                        <a:t>—</a:t>
+                      </a:r>
+                    </a:p>
+                  </a:txBody>
+                  <a:tcPr marL="73152" marR="73152" marT="27432" marB="27432" anchor="ctr">
+                    <a:solidFill>
+                      <a:srgbClr val="EAF3F5"/>
+                    </a:solidFill>
+                  </a:tcPr>
+                </a:tc>
+                <a:tc>
+                  <a:txBody>
+                    <a:bodyPr wrap="square"/>
+                    <a:lstStyle/>
+                    <a:p>
+                      <a:pPr algn="ctr"/>
+                      <a:r>
+                        <a:rPr sz="1400" b="1">
+                          <a:solidFill>
+                            <a:srgbClr val="137C8E"/>
+                          </a:solidFill>
+                          <a:latin typeface="Calibri"/>
+                        </a:rPr>
+                        <a:t>97.38 ± 0.74 %</a:t>
+                      </a:r>
+                    </a:p>
+                  </a:txBody>
+                  <a:tcPr marL="73152" marR="73152" marT="27432" marB="27432" anchor="ctr">
+                    <a:solidFill>
+                      <a:srgbClr val="EAF3F5"/>
+                    </a:solidFill>
+                  </a:tcPr>
+                </a:tc>
+                <a:tc>
+                  <a:txBody>
+                    <a:bodyPr wrap="square"/>
+                    <a:lstStyle/>
+                    <a:p>
+                      <a:pPr algn="ctr"/>
+                      <a:r>
+                        <a:rPr sz="1400" b="1">
+                          <a:solidFill>
+                            <a:srgbClr val="137C8E"/>
+                          </a:solidFill>
+                          <a:latin typeface="Calibri"/>
+                        </a:rPr>
+                        <a:t>96.64 ± 1.60 %</a:t>
+                      </a:r>
+                    </a:p>
+                  </a:txBody>
+                  <a:tcPr marL="73152" marR="73152" marT="27432" marB="27432" anchor="ctr">
+                    <a:solidFill>
+                      <a:srgbClr val="EAF3F5"/>
+                    </a:solidFill>
+                  </a:tcPr>
+                </a:tc>
+                <a:tc>
+                  <a:txBody>
+                    <a:bodyPr wrap="square"/>
+                    <a:lstStyle/>
+                    <a:p>
+                      <a:pPr algn="ctr"/>
+                      <a:r>
+                        <a:rPr sz="1400" b="1">
+                          <a:solidFill>
+                            <a:srgbClr val="137C8E"/>
+                          </a:solidFill>
+                          <a:latin typeface="Calibri"/>
+                        </a:rPr>
+                        <a:t>98.09 ± 0.18 %</a:t>
+                      </a:r>
+                    </a:p>
+                  </a:txBody>
+                  <a:tcPr marL="73152" marR="73152" marT="27432" marB="27432" anchor="ctr">
+                    <a:solidFill>
+                      <a:srgbClr val="EAF3F5"/>
+                    </a:solidFill>
+                  </a:tcPr>
+                </a:tc>
+                <a:tc>
+                  <a:txBody>
+                    <a:bodyPr wrap="square"/>
+                    <a:lstStyle/>
+                    <a:p>
+                      <a:pPr algn="ctr"/>
+                      <a:r>
+                        <a:rPr sz="1400" b="1">
+                          <a:solidFill>
+                            <a:srgbClr val="137C8E"/>
+                          </a:solidFill>
+                          <a:latin typeface="Calibri"/>
+                        </a:rPr>
+                        <a:t>0.95 ± 0.01</a:t>
+                      </a:r>
+                    </a:p>
+                  </a:txBody>
+                  <a:tcPr marL="73152" marR="73152" marT="27432" marB="27432" anchor="ctr">
+                    <a:solidFill>
+                      <a:srgbClr val="EAF3F5"/>
+                    </a:solidFill>
+                  </a:tcPr>
+                </a:tc>
+              </a:tr>
+            </a:tbl>
+          </a:graphicData>
+        </a:graphic>
+      </p:graphicFrame>
+      <p:sp>
+        <p:nvSpPr>
+          <p:cNvPr id="7" name="Shape 15"/>
+          <p:cNvSpPr/>
+          <p:nvPr/>
+        </p:nvSpPr>
+        <p:spPr>
+          <a:xfrm>
+            <a:off x="548640" y="4846320"/>
+            <a:ext cx="11091672" cy="868680"/>
+          </a:xfrm>
+          <a:prstGeom prst="roundRect">
+            <a:avLst>
+              <a:gd name="adj" fmla="val 10526"/>
+            </a:avLst>
+          </a:prstGeom>
+          <a:solidFill>
+            <a:srgbClr val="0F2E3D"/>
+          </a:solidFill>
+          <a:ln/>
+        </p:spPr>
+        <p:txBody>
+          <a:bodyPr/>
+          <a:p/>
+        </p:txBody>
+      </p:sp>
+      <p:sp>
+        <p:nvSpPr>
+          <p:cNvPr id="8" name="Shape 16"/>
+          <p:cNvSpPr/>
+          <p:nvPr/>
+        </p:nvSpPr>
+        <p:spPr>
+          <a:xfrm>
+            <a:off x="905256" y="4946904"/>
+            <a:ext cx="658368" cy="658368"/>
+          </a:xfrm>
+          <a:prstGeom prst="ellipse">
+            <a:avLst/>
+          </a:prstGeom>
+          <a:solidFill>
+            <a:srgbClr val="D99A00"/>
+          </a:solidFill>
+          <a:ln/>
+        </p:spPr>
+        <p:txBody>
+          <a:bodyPr/>
+          <a:p/>
+        </p:txBody>
+      </p:sp>
+      <p:sp>
+        <p:nvSpPr>
+          <p:cNvPr id="9" name="Text 17"/>
+          <p:cNvSpPr txBox="1"/>
+          <p:nvPr/>
+        </p:nvSpPr>
+        <p:spPr>
+          <a:xfrm>
+            <a:off x="1783080" y="4846320"/>
+            <a:ext cx="9601200" cy="868680"/>
+          </a:xfrm>
+          <a:prstGeom prst="rect">
+            <a:avLst/>
+          </a:prstGeom>
+          <a:noFill/>
+          <a:ln/>
+        </p:spPr>
+        <p:txBody>
+          <a:bodyPr wrap="square" lIns="0" tIns="0" rIns="0" bIns="0" rtlCol="0" anchor="ctr"/>
+          <a:lstStyle/>
+          <a:p>
+            <a:pPr indent="0" marL="0">
+              <a:lnSpc>
+                <a:spcPct val="105000"/>
+              </a:lnSpc>
+              <a:buNone/>
+            </a:pPr>
+            <a:r>
+              <a:rPr lang="en-US" sz="1550" b="1" dirty="0">
+                <a:solidFill>
+                  <a:srgbClr val="2EA79B"/>
+                </a:solidFill>
+                <a:latin typeface="Calibri" pitchFamily="34" charset="0"/>
+                <a:ea typeface="Calibri" pitchFamily="34" charset="-122"/>
+                <a:cs typeface="Calibri" pitchFamily="34" charset="-120"/>
+              </a:rPr>
+              <a:t>Fold 1 is the weakest:  </a:t>
+            </a:r>
+            <a:pPr indent="0" marL="0">
+              <a:lnSpc>
+                <a:spcPct val="105000"/>
+              </a:lnSpc>
+              <a:buNone/>
+            </a:pPr>
+            <a:r>
+              <a:rPr lang="en-US" sz="1550" dirty="0">
+                <a:solidFill>
+                  <a:srgbClr val="E8F2F4"/>
+                </a:solidFill>
+                <a:latin typeface="Calibri" pitchFamily="34" charset="0"/>
+                <a:ea typeface="Calibri" pitchFamily="34" charset="-122"/>
+                <a:cs typeface="Calibri" pitchFamily="34" charset="-120"/>
+              </a:rPr>
+              <a:t>recall 94.84 % (64 missed infected cells) vs. 97.90 % and 97.18 % on the other two folds.</a:t>
+            </a:r>
+            <a:endParaRPr lang="en-US" sz="1550" dirty="0"/>
+          </a:p>
+        </p:txBody>
+      </p:sp>
+      <p:pic>
+        <p:nvPicPr>
+          <p:cNvPr id="10" name="Picture 12" descr="image.png"/>
+          <p:cNvPicPr>
+            <a:picLocks noChangeAspect="1"/>
+          </p:cNvPicPr>
+          <p:nvPr/>
+        </p:nvPicPr>
+        <p:blipFill>
+          <a:blip r:embed="rId2"/>
+          <a:stretch>
+            <a:fillRect/>
+          </a:stretch>
+        </p:blipFill>
+        <p:spPr>
+          <a:xfrm>
+            <a:off x="1092708" y="5134356"/>
+            <a:ext cx="283464" cy="283464"/>
+          </a:xfrm>
+          <a:prstGeom prst="rect">
+            <a:avLst/>
+          </a:prstGeom>
+        </p:spPr>
+      </p:pic>
+      <p:sp>
+        <p:nvSpPr>
+          <p:cNvPr id="11" name="TextBox 10"/>
+          <p:cNvSpPr txBox="1"/>
+          <p:nvPr/>
+        </p:nvSpPr>
+        <p:spPr>
+          <a:xfrm>
+            <a:off x="548640" y="6455664"/>
+            <a:ext cx="7315200" cy="274320"/>
+          </a:xfrm>
+          <a:prstGeom prst="rect">
+            <a:avLst/>
+          </a:prstGeom>
+          <a:noFill/>
+        </p:spPr>
+        <p:txBody>
+          <a:bodyPr wrap="square" lIns="0" rIns="0" tIns="0" bIns="0" anchor="t">
+            <a:spAutoFit/>
+          </a:bodyPr>
+          <a:lstStyle/>
+          <a:p>
+            <a:pPr algn="l"/>
+            <a:r>
+              <a:rPr sz="900" b="0" i="0">
+                <a:solidFill>
+                  <a:srgbClr val="7C8B93"/>
+                </a:solidFill>
+                <a:latin typeface="Calibri"/>
+              </a:rPr>
+              <a:t>Phase 2 · Baseline &amp; Hypothesis · Automated Malaria Cell Detection</a:t>
+            </a:r>
+          </a:p>
+        </p:txBody>
+      </p:sp>
+      <p:sp>
+        <p:nvSpPr>
+          <p:cNvPr id="12" name="TextBox 11"/>
+          <p:cNvSpPr txBox="1"/>
+          <p:nvPr/>
+        </p:nvSpPr>
+        <p:spPr>
+          <a:xfrm>
+            <a:off x="11183112" y="6419088"/>
+            <a:ext cx="457200" cy="274320"/>
+          </a:xfrm>
+          <a:prstGeom prst="rect">
+            <a:avLst/>
+          </a:prstGeom>
+          <a:noFill/>
+        </p:spPr>
+        <p:txBody>
+          <a:bodyPr wrap="square" lIns="0" rIns="0" tIns="0" bIns="0" anchor="t">
+            <a:spAutoFit/>
+          </a:bodyPr>
+          <a:lstStyle/>
+          <a:p>
+            <a:pPr algn="r"/>
+            <a:r>
+              <a:rPr sz="1000" b="0" i="0">
+                <a:solidFill>
+                  <a:srgbClr val="7C8B93"/>
+                </a:solidFill>
+                <a:latin typeface="Calibri"/>
+              </a:rPr>
+              <a:t>21</a:t>
+            </a:r>
           </a:p>
         </p:txBody>
       </p:sp>

</xml_diff>